<commit_message>
Year 9 Exploring Science: larger slide text for projection
Body text 20pt, titles 34pt, key ideas 17pt, quick check and exit ticket
questions 20 to 22pt, with a fit check that steps a block down only when
it would overflow. Today slide shows the key words large in columns.
Diagram labels scaled up by a quarter and overlaps fixed. All decks,
worksheets and PDFs rebuilt.

Co-Authored-By: Claude Fable 5.1 <noreply@anthropic.com>
Claude-Session: https://claude.ai/code/session_01RjT1wLRvREoDuxifL3a92d
</commit_message>
<xml_diff>
--- a/Y9_Exploring_Science/9A_Genetics_and_evolution/9A_L01_Environmental_variation.pptx
+++ b/Y9_Exploring_Science/9A_Genetics_and_evolution/9A_L01_Environmental_variation.pptx
@@ -1740,7 +1740,7 @@
         <p:spPr>
           <a:xfrm>
             <a:off x="548640" y="3657600"/>
-            <a:ext cx="10515600" cy="914400"/>
+            <a:ext cx="10515600" cy="1097280"/>
           </a:xfrm>
           <a:prstGeom prst="rect">
             <a:avLst/>
@@ -1753,7 +1753,7 @@
           <a:lstStyle>
             <a:lvl1pPr indent="0" marL="0">
               <a:buNone/>
-              <a:defRPr lang="en-US" sz="2000" dirty="0">
+              <a:defRPr lang="en-US" sz="2400" dirty="0">
                 <a:solidFill>
                   <a:srgbClr val="FFFFFF"/>
                 </a:solidFill>
@@ -1764,7 +1764,7 @@
             <a:pPr indent="0" marL="0">
               <a:buNone/>
             </a:pPr>
-            <a:endParaRPr lang="en-US" sz="2000" dirty="0"/>
+            <a:endParaRPr lang="en-US" sz="2400" dirty="0"/>
           </a:p>
         </p:txBody>
       </p:sp>
@@ -1864,14 +1864,14 @@
               <a:buNone/>
             </a:pPr>
             <a:r>
-              <a:rPr lang="en-US" sz="900" dirty="0">
+              <a:rPr lang="en-US" sz="1000" dirty="0">
                 <a:solidFill>
                   <a:srgbClr val="5B6574"/>
                 </a:solidFill>
               </a:rPr>
               <a:t>Year 9 Science  |  9A Genetics and evolution  |  Lesson 1: Environmental variation</a:t>
             </a:r>
-            <a:endParaRPr lang="en-US" sz="900" dirty="0"/>
+            <a:endParaRPr lang="en-US" sz="1000" dirty="0"/>
           </a:p>
         </p:txBody>
       </p:sp>
@@ -2040,14 +2040,14 @@
               <a:buNone/>
             </a:pPr>
             <a:r>
-              <a:rPr lang="en-US" sz="900" dirty="0">
+              <a:rPr lang="en-US" sz="1000" dirty="0">
                 <a:solidFill>
                   <a:srgbClr val="5B6574"/>
                 </a:solidFill>
               </a:rPr>
               <a:t>Year 9 Science  |  9A Genetics and evolution  |  Lesson 1: Environmental variation</a:t>
             </a:r>
-            <a:endParaRPr lang="en-US" sz="900" dirty="0"/>
+            <a:endParaRPr lang="en-US" sz="1000" dirty="0"/>
           </a:p>
         </p:txBody>
       </p:sp>
@@ -2216,14 +2216,14 @@
               <a:buNone/>
             </a:pPr>
             <a:r>
-              <a:rPr lang="en-US" sz="900" dirty="0">
+              <a:rPr lang="en-US" sz="1000" dirty="0">
                 <a:solidFill>
                   <a:srgbClr val="5B6574"/>
                 </a:solidFill>
               </a:rPr>
               <a:t>Year 9 Science  |  9A Genetics and evolution  |  Lesson 1: Environmental variation</a:t>
             </a:r>
-            <a:endParaRPr lang="en-US" sz="900" dirty="0"/>
+            <a:endParaRPr lang="en-US" sz="1000" dirty="0"/>
           </a:p>
         </p:txBody>
       </p:sp>
@@ -2352,7 +2352,7 @@
           <a:lstStyle>
             <a:lvl1pPr indent="0" marL="0">
               <a:buNone/>
-              <a:defRPr lang="en-US" sz="3000" b="1" dirty="0">
+              <a:defRPr lang="en-US" sz="3400" b="1" dirty="0">
                 <a:solidFill>
                   <a:srgbClr val="3A2E00"/>
                 </a:solidFill>
@@ -2363,7 +2363,7 @@
             <a:pPr indent="0" marL="0">
               <a:buNone/>
             </a:pPr>
-            <a:endParaRPr lang="en-US" sz="3000" dirty="0"/>
+            <a:endParaRPr lang="en-US" sz="3400" dirty="0"/>
           </a:p>
         </p:txBody>
       </p:sp>
@@ -2780,14 +2780,14 @@
               <a:buNone/>
             </a:pPr>
             <a:r>
-              <a:rPr lang="en-US" sz="1300" b="1" spc="200" kern="0" dirty="0">
+              <a:rPr lang="en-US" sz="1400" b="1" spc="200" kern="0" dirty="0">
                 <a:solidFill>
                   <a:srgbClr val="F2CE3E"/>
                 </a:solidFill>
               </a:rPr>
               <a:t>YEAR 9 SCIENCE  ·  9A GENETICS AND EVOLUTION  ·  LESSON 1 OF 7</a:t>
             </a:r>
-            <a:endParaRPr lang="en-US" sz="1300" dirty="0"/>
+            <a:endParaRPr lang="en-US" sz="1400" dirty="0"/>
           </a:p>
         </p:txBody>
       </p:sp>
@@ -2840,7 +2840,7 @@
         <p:spPr>
           <a:xfrm>
             <a:off x="548640" y="3657600"/>
-            <a:ext cx="10515600" cy="914400"/>
+            <a:ext cx="10515600" cy="1097280"/>
           </a:xfrm>
           <a:prstGeom prst="rect">
             <a:avLst/>
@@ -2856,14 +2856,14 @@
               <a:buNone/>
             </a:pPr>
             <a:r>
-              <a:rPr lang="en-US" sz="2000" dirty="0">
+              <a:rPr lang="en-US" sz="2400" dirty="0">
                 <a:solidFill>
                   <a:srgbClr val="FFFFFF"/>
                 </a:solidFill>
               </a:rPr>
               <a:t>Why do the same kind of organism come in so many sizes, shapes and colours?</a:t>
             </a:r>
-            <a:endParaRPr lang="en-US" sz="2000" dirty="0"/>
+            <a:endParaRPr lang="en-US" sz="2400" dirty="0"/>
           </a:p>
         </p:txBody>
       </p:sp>
@@ -2892,14 +2892,14 @@
               <a:buNone/>
             </a:pPr>
             <a:r>
-              <a:rPr lang="en-US" sz="1200" dirty="0">
+              <a:rPr lang="en-US" sz="1400" dirty="0">
                 <a:solidFill>
                   <a:srgbClr val="C9D3E6"/>
                 </a:solidFill>
               </a:rPr>
               <a:t>Exploring Science International 9  ·  Student Book pages 5 to 7  ·  Workbook pages 3 to 4</a:t>
             </a:r>
-            <a:endParaRPr lang="en-US" sz="1200" dirty="0"/>
+            <a:endParaRPr lang="en-US" sz="1400" dirty="0"/>
           </a:p>
         </p:txBody>
       </p:sp>
@@ -3207,23 +3207,21 @@
           <a:ln/>
         </p:spPr>
         <p:txBody>
-          <a:bodyPr wrap="square" lIns="0" tIns="0" rIns="0" bIns="0" rtlCol="0" anchor="t">
-            <a:normAutofit/>
-          </a:bodyPr>
+          <a:bodyPr wrap="square" lIns="0" tIns="0" rIns="0" bIns="0" rtlCol="0" anchor="t"/>
           <a:lstStyle/>
           <a:p>
             <a:pPr indent="0" marL="0">
               <a:buNone/>
             </a:pPr>
             <a:r>
-              <a:rPr lang="en-US" sz="1700" dirty="0">
+              <a:rPr lang="en-US" sz="2000" dirty="0">
                 <a:solidFill>
                   <a:srgbClr val="141B26"/>
                 </a:solidFill>
               </a:rPr>
               <a:t>Core: match the key words, sort the factors, then tally and plot the potato masses on the grid.</a:t>
             </a:r>
-            <a:endParaRPr lang="en-US" sz="1700" dirty="0"/>
+            <a:endParaRPr lang="en-US" sz="2000" dirty="0"/>
           </a:p>
         </p:txBody>
       </p:sp>
@@ -3306,23 +3304,21 @@
           <a:ln/>
         </p:spPr>
         <p:txBody>
-          <a:bodyPr wrap="square" lIns="0" tIns="0" rIns="0" bIns="0" rtlCol="0" anchor="t">
-            <a:normAutofit/>
-          </a:bodyPr>
+          <a:bodyPr wrap="square" lIns="0" tIns="0" rIns="0" bIns="0" rtlCol="0" anchor="t"/>
           <a:lstStyle/>
           <a:p>
             <a:pPr indent="0" marL="0">
               <a:buNone/>
             </a:pPr>
             <a:r>
-              <a:rPr lang="en-US" sz="1700" dirty="0">
+              <a:rPr lang="en-US" sz="2000" dirty="0">
                 <a:solidFill>
                   <a:srgbClr val="141B26"/>
                 </a:solidFill>
               </a:rPr>
               <a:t>Grouped continuous data: the bars touch. Label both axes and give the chart a title.</a:t>
             </a:r>
-            <a:endParaRPr lang="en-US" sz="1700" dirty="0"/>
+            <a:endParaRPr lang="en-US" sz="2000" dirty="0"/>
           </a:p>
         </p:txBody>
       </p:sp>
@@ -3405,23 +3401,21 @@
           <a:ln/>
         </p:spPr>
         <p:txBody>
-          <a:bodyPr wrap="square" lIns="0" tIns="0" rIns="0" bIns="0" rtlCol="0" anchor="t">
-            <a:normAutofit/>
-          </a:bodyPr>
+          <a:bodyPr wrap="square" lIns="0" tIns="0" rIns="0" bIns="0" rtlCol="0" anchor="t"/>
           <a:lstStyle/>
           <a:p>
             <a:pPr indent="0" marL="0">
               <a:buNone/>
             </a:pPr>
             <a:r>
-              <a:rPr lang="en-US" sz="1700" dirty="0">
+              <a:rPr lang="en-US" sz="2000" dirty="0">
                 <a:solidFill>
                   <a:srgbClr val="141B26"/>
                 </a:solidFill>
               </a:rPr>
               <a:t>Stretch: examples of environmental variation; continuous or discontinuous; why do the potatoes vary?</a:t>
             </a:r>
-            <a:endParaRPr lang="en-US" sz="1700" dirty="0"/>
+            <a:endParaRPr lang="en-US" sz="2000" dirty="0"/>
           </a:p>
         </p:txBody>
       </p:sp>
@@ -3504,23 +3498,21 @@
           <a:ln/>
         </p:spPr>
         <p:txBody>
-          <a:bodyPr wrap="square" lIns="0" tIns="0" rIns="0" bIns="0" rtlCol="0" anchor="t">
-            <a:normAutofit/>
-          </a:bodyPr>
+          <a:bodyPr wrap="square" lIns="0" tIns="0" rIns="0" bIns="0" rtlCol="0" anchor="t"/>
           <a:lstStyle/>
           <a:p>
             <a:pPr indent="0" marL="0">
               <a:buNone/>
             </a:pPr>
             <a:r>
-              <a:rPr lang="en-US" sz="1700" dirty="0">
+              <a:rPr lang="en-US" sz="2000" dirty="0">
                 <a:solidFill>
                   <a:srgbClr val="141B26"/>
                 </a:solidFill>
               </a:rPr>
               <a:t>Challenge: the seashore plants and the Flores Island bones.</a:t>
             </a:r>
-            <a:endParaRPr lang="en-US" sz="1700" dirty="0"/>
+            <a:endParaRPr lang="en-US" sz="2000" dirty="0"/>
           </a:p>
         </p:txBody>
       </p:sp>
@@ -3603,23 +3595,21 @@
           <a:ln/>
         </p:spPr>
         <p:txBody>
-          <a:bodyPr wrap="square" lIns="0" tIns="0" rIns="0" bIns="0" rtlCol="0" anchor="t">
-            <a:normAutofit/>
-          </a:bodyPr>
+          <a:bodyPr wrap="square" lIns="0" tIns="0" rIns="0" bIns="0" rtlCol="0" anchor="t"/>
           <a:lstStyle/>
           <a:p>
             <a:pPr indent="0" marL="0">
               <a:buNone/>
             </a:pPr>
             <a:r>
-              <a:rPr lang="en-US" sz="1700" dirty="0">
+              <a:rPr lang="en-US" sz="2000" dirty="0">
                 <a:solidFill>
                   <a:srgbClr val="141B26"/>
                 </a:solidFill>
               </a:rPr>
               <a:t>Finished? Write a question for the class in the My thinking box.</a:t>
             </a:r>
-            <a:endParaRPr lang="en-US" sz="1700" dirty="0"/>
+            <a:endParaRPr lang="en-US" sz="2000" dirty="0"/>
           </a:p>
         </p:txBody>
       </p:sp>
@@ -3648,14 +3638,14 @@
               <a:buNone/>
             </a:pPr>
             <a:r>
-              <a:rPr lang="en-US" sz="1300" i="1" dirty="0">
+              <a:rPr lang="en-US" sz="1500" i="1" dirty="0">
                 <a:solidFill>
                   <a:srgbClr val="5B6574"/>
                 </a:solidFill>
               </a:rPr>
               <a:t>Work alone first. Check your bar chart with a partner before Stretch.</a:t>
             </a:r>
-            <a:endParaRPr lang="en-US" sz="1300" dirty="0"/>
+            <a:endParaRPr lang="en-US" sz="1500" dirty="0"/>
           </a:p>
         </p:txBody>
       </p:sp>
@@ -3848,23 +3838,21 @@
           <a:ln/>
         </p:spPr>
         <p:txBody>
-          <a:bodyPr wrap="square" lIns="0" tIns="0" rIns="0" bIns="0" rtlCol="0" anchor="t">
-            <a:normAutofit/>
-          </a:bodyPr>
+          <a:bodyPr wrap="square" lIns="0" tIns="0" rIns="0" bIns="0" rtlCol="0" anchor="t"/>
           <a:lstStyle/>
           <a:p>
             <a:pPr indent="0" marL="0">
               <a:buNone/>
             </a:pPr>
             <a:r>
-              <a:rPr lang="en-US" sz="2200" b="1" dirty="0">
+              <a:rPr lang="en-US" sz="2600" b="1" dirty="0">
                 <a:solidFill>
                   <a:srgbClr val="0F2A5F"/>
                 </a:solidFill>
               </a:rPr>
               <a:t>Seashore plants: 10 cm tall with pink flowers. On a nearby island: over 50 cm tall with dark purple flowers. Seeds from both were grown in a laboratory. They all grew to look the same. What does this tell you?</a:t>
             </a:r>
-            <a:endParaRPr lang="en-US" sz="2200" dirty="0"/>
+            <a:endParaRPr lang="en-US" sz="2600" dirty="0"/>
           </a:p>
         </p:txBody>
       </p:sp>
@@ -3913,9 +3901,7 @@
           <a:ln/>
         </p:spPr>
         <p:txBody>
-          <a:bodyPr wrap="square" lIns="0" tIns="0" rIns="0" bIns="0" rtlCol="0" anchor="t">
-            <a:normAutofit/>
-          </a:bodyPr>
+          <a:bodyPr wrap="square" lIns="0" tIns="0" rIns="0" bIns="0" rtlCol="0" anchor="t"/>
           <a:lstStyle/>
           <a:p>
             <a:pPr indent="0" marL="0">
@@ -3925,14 +3911,14 @@
               <a:buNone/>
             </a:pPr>
             <a:r>
-              <a:rPr lang="en-US" sz="1500" b="1" dirty="0">
+              <a:rPr lang="en-US" sz="1800" b="1" dirty="0">
                 <a:solidFill>
                   <a:srgbClr val="7B3A8E"/>
                 </a:solidFill>
               </a:rPr>
               <a:t>Sentence frames</a:t>
             </a:r>
-            <a:endParaRPr lang="en-US" sz="1500" dirty="0"/>
+            <a:endParaRPr lang="en-US" sz="1800" dirty="0"/>
           </a:p>
           <a:p>
             <a:pPr indent="0" marL="0">
@@ -3942,14 +3928,14 @@
               <a:buNone/>
             </a:pPr>
             <a:r>
-              <a:rPr lang="en-US" sz="1500" dirty="0">
+              <a:rPr lang="en-US" sz="1800" dirty="0">
                 <a:solidFill>
                   <a:srgbClr val="141B26"/>
                 </a:solidFill>
               </a:rPr>
               <a:t>The plants from the two areas are probably ___ because ___.</a:t>
             </a:r>
-            <a:endParaRPr lang="en-US" sz="1500" dirty="0"/>
+            <a:endParaRPr lang="en-US" sz="1800" dirty="0"/>
           </a:p>
           <a:p>
             <a:pPr indent="0" marL="0">
@@ -3959,14 +3945,14 @@
               <a:buNone/>
             </a:pPr>
             <a:r>
-              <a:rPr lang="en-US" sz="1500" dirty="0">
+              <a:rPr lang="en-US" sz="1800" dirty="0">
                 <a:solidFill>
                   <a:srgbClr val="141B26"/>
                 </a:solidFill>
               </a:rPr>
               <a:t>The differences in height and colour were caused by ___.</a:t>
             </a:r>
-            <a:endParaRPr lang="en-US" sz="1500" dirty="0"/>
+            <a:endParaRPr lang="en-US" sz="1800" dirty="0"/>
           </a:p>
           <a:p>
             <a:pPr indent="0" marL="0">
@@ -3976,14 +3962,14 @@
               <a:buNone/>
             </a:pPr>
             <a:r>
-              <a:rPr lang="en-US" sz="1500" dirty="0">
+              <a:rPr lang="en-US" sz="1800" dirty="0">
                 <a:solidFill>
                   <a:srgbClr val="141B26"/>
                 </a:solidFill>
               </a:rPr>
               <a:t>This makes it difficult to ___ because ___.</a:t>
             </a:r>
-            <a:endParaRPr lang="en-US" sz="1500" dirty="0"/>
+            <a:endParaRPr lang="en-US" sz="1800" dirty="0"/>
           </a:p>
         </p:txBody>
       </p:sp>
@@ -4183,14 +4169,14 @@
               <a:buNone/>
             </a:pPr>
             <a:r>
-              <a:rPr lang="en-US" sz="1400" i="1" dirty="0">
+              <a:rPr lang="en-US" sz="1600" i="1" dirty="0">
                 <a:solidFill>
                   <a:srgbClr val="5B6574"/>
                 </a:solidFill>
               </a:rPr>
               <a:t>On your worksheet exit ticket. Work alone. Hand it in as you leave.</a:t>
             </a:r>
-            <a:endParaRPr lang="en-US" sz="1400" dirty="0"/>
+            <a:endParaRPr lang="en-US" sz="1600" dirty="0"/>
           </a:p>
         </p:txBody>
       </p:sp>
@@ -4203,25 +4189,23 @@
         <p:spPr>
           <a:xfrm>
             <a:off x="548640" y="1828800"/>
-            <a:ext cx="10881360" cy="1188720"/>
-          </a:xfrm>
-          <a:prstGeom prst="rect">
-            <a:avLst/>
-          </a:prstGeom>
-          <a:noFill/>
-          <a:ln/>
-        </p:spPr>
-        <p:txBody>
-          <a:bodyPr wrap="square" lIns="0" tIns="0" rIns="0" bIns="0" rtlCol="0" anchor="t">
-            <a:normAutofit/>
-          </a:bodyPr>
+            <a:ext cx="9692640" cy="1188720"/>
+          </a:xfrm>
+          <a:prstGeom prst="rect">
+            <a:avLst/>
+          </a:prstGeom>
+          <a:noFill/>
+          <a:ln/>
+        </p:spPr>
+        <p:txBody>
+          <a:bodyPr wrap="square" lIns="0" tIns="0" rIns="0" bIns="0" rtlCol="0" anchor="t"/>
           <a:lstStyle/>
           <a:p>
             <a:pPr indent="0" marL="0">
               <a:buNone/>
             </a:pPr>
             <a:r>
-              <a:rPr lang="en-US" sz="1800" b="1" dirty="0">
+              <a:rPr lang="en-US" sz="2200" b="1" dirty="0">
                 <a:solidFill>
                   <a:srgbClr val="7B3A8E"/>
                 </a:solidFill>
@@ -4232,14 +4216,14 @@
               <a:buNone/>
             </a:pPr>
             <a:r>
-              <a:rPr lang="en-US" sz="1800" dirty="0">
+              <a:rPr lang="en-US" sz="2200" dirty="0">
                 <a:solidFill>
                   <a:srgbClr val="141B26"/>
                 </a:solidFill>
               </a:rPr>
               <a:t>Give one abiotic factor and one biotic factor in a pond.</a:t>
             </a:r>
-            <a:endParaRPr lang="en-US" sz="1800" dirty="0"/>
+            <a:endParaRPr lang="en-US" sz="2200" dirty="0"/>
           </a:p>
         </p:txBody>
       </p:sp>
@@ -4252,25 +4236,23 @@
         <p:spPr>
           <a:xfrm>
             <a:off x="548640" y="3017520"/>
-            <a:ext cx="10881360" cy="1188720"/>
-          </a:xfrm>
-          <a:prstGeom prst="rect">
-            <a:avLst/>
-          </a:prstGeom>
-          <a:noFill/>
-          <a:ln/>
-        </p:spPr>
-        <p:txBody>
-          <a:bodyPr wrap="square" lIns="0" tIns="0" rIns="0" bIns="0" rtlCol="0" anchor="t">
-            <a:normAutofit/>
-          </a:bodyPr>
+            <a:ext cx="9692640" cy="1188720"/>
+          </a:xfrm>
+          <a:prstGeom prst="rect">
+            <a:avLst/>
+          </a:prstGeom>
+          <a:noFill/>
+          <a:ln/>
+        </p:spPr>
+        <p:txBody>
+          <a:bodyPr wrap="square" lIns="0" tIns="0" rIns="0" bIns="0" rtlCol="0" anchor="t"/>
           <a:lstStyle/>
           <a:p>
             <a:pPr indent="0" marL="0">
               <a:buNone/>
             </a:pPr>
             <a:r>
-              <a:rPr lang="en-US" sz="1800" b="1" dirty="0">
+              <a:rPr lang="en-US" sz="2200" b="1" dirty="0">
                 <a:solidFill>
                   <a:srgbClr val="7B3A8E"/>
                 </a:solidFill>
@@ -4281,14 +4263,14 @@
               <a:buNone/>
             </a:pPr>
             <a:r>
-              <a:rPr lang="en-US" sz="1800" dirty="0">
+              <a:rPr lang="en-US" sz="2200" dirty="0">
                 <a:solidFill>
                   <a:srgbClr val="141B26"/>
                 </a:solidFill>
               </a:rPr>
               <a:t>Is a scar an example of inherited or environmental variation?</a:t>
             </a:r>
-            <a:endParaRPr lang="en-US" sz="1800" dirty="0"/>
+            <a:endParaRPr lang="en-US" sz="2200" dirty="0"/>
           </a:p>
         </p:txBody>
       </p:sp>
@@ -4301,25 +4283,23 @@
         <p:spPr>
           <a:xfrm>
             <a:off x="548640" y="4206240"/>
-            <a:ext cx="10881360" cy="1188720"/>
-          </a:xfrm>
-          <a:prstGeom prst="rect">
-            <a:avLst/>
-          </a:prstGeom>
-          <a:noFill/>
-          <a:ln/>
-        </p:spPr>
-        <p:txBody>
-          <a:bodyPr wrap="square" lIns="0" tIns="0" rIns="0" bIns="0" rtlCol="0" anchor="t">
-            <a:normAutofit/>
-          </a:bodyPr>
+            <a:ext cx="9692640" cy="1188720"/>
+          </a:xfrm>
+          <a:prstGeom prst="rect">
+            <a:avLst/>
+          </a:prstGeom>
+          <a:noFill/>
+          <a:ln/>
+        </p:spPr>
+        <p:txBody>
+          <a:bodyPr wrap="square" lIns="0" tIns="0" rIns="0" bIns="0" rtlCol="0" anchor="t"/>
           <a:lstStyle/>
           <a:p>
             <a:pPr indent="0" marL="0">
               <a:buNone/>
             </a:pPr>
             <a:r>
-              <a:rPr lang="en-US" sz="1800" b="1" dirty="0">
+              <a:rPr lang="en-US" sz="2200" b="1" dirty="0">
                 <a:solidFill>
                   <a:srgbClr val="7B3A8E"/>
                 </a:solidFill>
@@ -4330,14 +4310,14 @@
               <a:buNone/>
             </a:pPr>
             <a:r>
-              <a:rPr lang="en-US" sz="1800" dirty="0">
+              <a:rPr lang="en-US" sz="2200" dirty="0">
                 <a:solidFill>
                   <a:srgbClr val="141B26"/>
                 </a:solidFill>
               </a:rPr>
               <a:t>Is foot length continuous or discontinuous variation? Give a reason.</a:t>
             </a:r>
-            <a:endParaRPr lang="en-US" sz="1800" dirty="0"/>
+            <a:endParaRPr lang="en-US" sz="2200" dirty="0"/>
           </a:p>
         </p:txBody>
       </p:sp>
@@ -4596,90 +4576,88 @@
         <p:spPr>
           <a:xfrm>
             <a:off x="548640" y="1371600"/>
-            <a:ext cx="10881360" cy="4480560"/>
-          </a:xfrm>
-          <a:prstGeom prst="rect">
-            <a:avLst/>
-          </a:prstGeom>
-          <a:noFill/>
-          <a:ln/>
-        </p:spPr>
-        <p:txBody>
-          <a:bodyPr wrap="square" lIns="0" tIns="0" rIns="0" bIns="0" rtlCol="0" anchor="t">
-            <a:normAutofit/>
-          </a:bodyPr>
+            <a:ext cx="10881360" cy="4114800"/>
+          </a:xfrm>
+          <a:prstGeom prst="rect">
+            <a:avLst/>
+          </a:prstGeom>
+          <a:noFill/>
+          <a:ln/>
+        </p:spPr>
+        <p:txBody>
+          <a:bodyPr wrap="square" lIns="0" tIns="0" rIns="0" bIns="0" rtlCol="0" anchor="t"/>
           <a:lstStyle/>
           <a:p>
             <a:pPr marL="342900" indent="-342900">
               <a:spcAft>
-                <a:spcPts val="1000"/>
+                <a:spcPts val="1200"/>
               </a:spcAft>
               <a:buSzPct val="100000"/>
               <a:buChar char="✓"/>
             </a:pPr>
             <a:r>
-              <a:rPr lang="en-US" sz="1700" dirty="0">
+              <a:rPr lang="en-US" sz="2000" dirty="0">
                 <a:solidFill>
                   <a:srgbClr val="141B26"/>
                 </a:solidFill>
               </a:rPr>
               <a:t>Environmental factors are abiotic (non-living) or biotic (other organisms).</a:t>
             </a:r>
-            <a:endParaRPr lang="en-US" sz="1700" dirty="0"/>
+            <a:endParaRPr lang="en-US" sz="2000" dirty="0"/>
           </a:p>
           <a:p>
             <a:pPr marL="342900" indent="-342900">
               <a:spcAft>
-                <a:spcPts val="1000"/>
+                <a:spcPts val="1200"/>
               </a:spcAft>
               <a:buSzPct val="100000"/>
               <a:buChar char="✓"/>
             </a:pPr>
             <a:r>
-              <a:rPr lang="en-US" sz="1700" dirty="0">
+              <a:rPr lang="en-US" sz="2000" dirty="0">
                 <a:solidFill>
                   <a:srgbClr val="141B26"/>
                 </a:solidFill>
               </a:rPr>
               <a:t>Environmental variation is caused by the surroundings and is not inherited.</a:t>
             </a:r>
-            <a:endParaRPr lang="en-US" sz="1700" dirty="0"/>
+            <a:endParaRPr lang="en-US" sz="2000" dirty="0"/>
           </a:p>
           <a:p>
             <a:pPr marL="342900" indent="-342900">
               <a:spcAft>
-                <a:spcPts val="1000"/>
+                <a:spcPts val="1200"/>
               </a:spcAft>
               <a:buSzPct val="100000"/>
               <a:buChar char="✓"/>
             </a:pPr>
             <a:r>
-              <a:rPr lang="en-US" sz="1700" dirty="0">
+              <a:rPr lang="en-US" sz="2000" dirty="0">
                 <a:solidFill>
                   <a:srgbClr val="141B26"/>
                 </a:solidFill>
               </a:rPr>
               <a:t>Continuous variation can take any value; discontinuous variation has a limited set of values.</a:t>
             </a:r>
-            <a:endParaRPr lang="en-US" sz="1700" dirty="0"/>
+            <a:endParaRPr lang="en-US" sz="2000" dirty="0"/>
           </a:p>
           <a:p>
             <a:pPr marL="342900" indent="-342900">
               <a:spcAft>
-                <a:spcPts val="1000"/>
+                <a:spcPts val="1200"/>
               </a:spcAft>
               <a:buSzPct val="100000"/>
               <a:buChar char="✓"/>
             </a:pPr>
             <a:r>
-              <a:rPr lang="en-US" sz="1700" dirty="0">
+              <a:rPr lang="en-US" sz="2000" dirty="0">
                 <a:solidFill>
                   <a:srgbClr val="141B26"/>
                 </a:solidFill>
               </a:rPr>
               <a:t>A species is a group that can breed together; environmental variation can make classifying organisms difficult.</a:t>
             </a:r>
-            <a:endParaRPr lang="en-US" sz="1700" dirty="0"/>
+            <a:endParaRPr lang="en-US" sz="2000" dirty="0"/>
           </a:p>
         </p:txBody>
       </p:sp>
@@ -4994,77 +4972,75 @@
           <a:ln/>
         </p:spPr>
         <p:txBody>
-          <a:bodyPr wrap="square" lIns="0" tIns="0" rIns="0" bIns="0" rtlCol="0" anchor="t">
-            <a:normAutofit/>
-          </a:bodyPr>
+          <a:bodyPr wrap="square" lIns="0" tIns="0" rIns="0" bIns="0" rtlCol="0" anchor="t"/>
           <a:lstStyle/>
           <a:p>
             <a:pPr indent="0" marL="0">
               <a:spcAft>
-                <a:spcPts val="1000"/>
+                <a:spcPts val="1200"/>
               </a:spcAft>
               <a:buNone/>
             </a:pPr>
             <a:r>
-              <a:rPr lang="en-US" sz="2000" dirty="0">
+              <a:rPr lang="en-US" sz="2400" dirty="0">
                 <a:solidFill>
                   <a:srgbClr val="141B26"/>
                 </a:solidFill>
               </a:rPr>
               <a:t>A story says these bones are from a fire-breathing dragon killed by Krak, a shoemaker's apprentice.</a:t>
             </a:r>
-            <a:endParaRPr lang="en-US" sz="2000" dirty="0"/>
+            <a:endParaRPr lang="en-US" sz="2400" dirty="0"/>
           </a:p>
           <a:p>
             <a:pPr indent="0" marL="0">
               <a:spcAft>
-                <a:spcPts val="1000"/>
+                <a:spcPts val="1200"/>
               </a:spcAft>
               <a:buNone/>
             </a:pPr>
             <a:r>
-              <a:rPr lang="en-US" sz="2000" dirty="0">
+              <a:rPr lang="en-US" sz="2400" dirty="0">
                 <a:solidFill>
                   <a:srgbClr val="141B26"/>
                 </a:solidFill>
               </a:rPr>
               <a:t>1. What animals could the bones really be from?</a:t>
             </a:r>
-            <a:endParaRPr lang="en-US" sz="2000" dirty="0"/>
+            <a:endParaRPr lang="en-US" sz="2400" dirty="0"/>
           </a:p>
           <a:p>
             <a:pPr indent="0" marL="0">
               <a:spcAft>
-                <a:spcPts val="1000"/>
+                <a:spcPts val="1200"/>
               </a:spcAft>
               <a:buNone/>
             </a:pPr>
             <a:r>
-              <a:rPr lang="en-US" sz="2000" dirty="0">
+              <a:rPr lang="en-US" sz="2400" dirty="0">
                 <a:solidFill>
                   <a:srgbClr val="141B26"/>
                 </a:solidFill>
               </a:rPr>
               <a:t>2. What does 'extinct' mean?</a:t>
             </a:r>
-            <a:endParaRPr lang="en-US" sz="2000" dirty="0"/>
+            <a:endParaRPr lang="en-US" sz="2400" dirty="0"/>
           </a:p>
           <a:p>
             <a:pPr indent="0" marL="0">
               <a:spcAft>
-                <a:spcPts val="1000"/>
+                <a:spcPts val="1200"/>
               </a:spcAft>
               <a:buNone/>
             </a:pPr>
             <a:r>
-              <a:rPr lang="en-US" sz="2000" dirty="0">
+              <a:rPr lang="en-US" sz="2400" dirty="0">
                 <a:solidFill>
                   <a:srgbClr val="141B26"/>
                 </a:solidFill>
               </a:rPr>
               <a:t>3. Name one species that is extinct.</a:t>
             </a:r>
-            <a:endParaRPr lang="en-US" sz="2000" dirty="0"/>
+            <a:endParaRPr lang="en-US" sz="2400" dirty="0"/>
           </a:p>
         </p:txBody>
       </p:sp>
@@ -5101,7 +5077,7 @@
         <p:spPr>
           <a:xfrm>
             <a:off x="6858000" y="5166360"/>
-            <a:ext cx="4754880" cy="502920"/>
+            <a:ext cx="4754880" cy="548640"/>
           </a:xfrm>
           <a:prstGeom prst="rect">
             <a:avLst/>
@@ -5117,7 +5093,7 @@
               <a:buNone/>
             </a:pPr>
             <a:r>
-              <a:rPr lang="en-US" sz="1100" dirty="0">
+              <a:rPr lang="en-US" sz="1300" dirty="0">
                 <a:solidFill>
                   <a:srgbClr val="141B26"/>
                 </a:solidFill>
@@ -5127,21 +5103,21 @@
             <a:pPr algn="l" indent="0" marL="0">
               <a:buNone/>
             </a:pPr>
-            <a:endParaRPr lang="en-US" sz="1100" dirty="0"/>
+            <a:endParaRPr lang="en-US" sz="1300" dirty="0"/>
           </a:p>
           <a:p>
             <a:pPr algn="l" indent="0" marL="0">
               <a:buNone/>
             </a:pPr>
             <a:r>
-              <a:rPr lang="en-US" sz="800" dirty="0">
+              <a:rPr lang="en-US" sz="900" dirty="0">
                 <a:solidFill>
                   <a:srgbClr val="5B6574"/>
                 </a:solidFill>
               </a:rPr>
               <a:t>Image: nedrichards, CC BY-SA 2.0, via Wikimedia Commons</a:t>
             </a:r>
-            <a:endParaRPr lang="en-US" sz="1100" dirty="0"/>
+            <a:endParaRPr lang="en-US" sz="1300" dirty="0"/>
           </a:p>
         </p:txBody>
       </p:sp>
@@ -5324,8 +5300,8 @@
         </p:nvSpPr>
         <p:spPr>
           <a:xfrm>
-            <a:off x="548640" y="1325880"/>
-            <a:ext cx="5669280" cy="457200"/>
+            <a:off x="548640" y="1280160"/>
+            <a:ext cx="5486400" cy="411480"/>
           </a:xfrm>
           <a:prstGeom prst="rect">
             <a:avLst/>
@@ -5341,14 +5317,14 @@
               <a:buNone/>
             </a:pPr>
             <a:r>
-              <a:rPr lang="en-US" sz="2000" b="1" dirty="0">
+              <a:rPr lang="en-US" sz="2200" b="1" dirty="0">
                 <a:solidFill>
                   <a:srgbClr val="7B3A8E"/>
                 </a:solidFill>
               </a:rPr>
               <a:t>Today I can ...</a:t>
             </a:r>
-            <a:endParaRPr lang="en-US" sz="2000" dirty="0"/>
+            <a:endParaRPr lang="en-US" sz="2200" dirty="0"/>
           </a:p>
         </p:txBody>
       </p:sp>
@@ -5360,8 +5336,8 @@
         </p:nvSpPr>
         <p:spPr>
           <a:xfrm>
-            <a:off x="594360" y="1947672"/>
-            <a:ext cx="292608" cy="292608"/>
+            <a:off x="594360" y="1810512"/>
+            <a:ext cx="310896" cy="310896"/>
           </a:xfrm>
           <a:prstGeom prst="rect">
             <a:avLst/>
@@ -5385,33 +5361,31 @@
         </p:nvSpPr>
         <p:spPr>
           <a:xfrm>
-            <a:off x="1051560" y="1874520"/>
-            <a:ext cx="5120640" cy="868680"/>
-          </a:xfrm>
-          <a:prstGeom prst="rect">
-            <a:avLst/>
-          </a:prstGeom>
-          <a:noFill/>
-          <a:ln/>
-        </p:spPr>
-        <p:txBody>
-          <a:bodyPr wrap="square" lIns="0" tIns="0" rIns="0" bIns="0" rtlCol="0" anchor="t">
-            <a:normAutofit/>
-          </a:bodyPr>
+            <a:off x="1097280" y="1737360"/>
+            <a:ext cx="10332720" cy="868680"/>
+          </a:xfrm>
+          <a:prstGeom prst="rect">
+            <a:avLst/>
+          </a:prstGeom>
+          <a:noFill/>
+          <a:ln/>
+        </p:spPr>
+        <p:txBody>
+          <a:bodyPr wrap="square" lIns="0" tIns="0" rIns="0" bIns="0" rtlCol="0" anchor="t"/>
           <a:lstStyle/>
           <a:p>
             <a:pPr indent="0" marL="0">
               <a:buNone/>
             </a:pPr>
             <a:r>
-              <a:rPr lang="en-US" sz="1600" dirty="0">
+              <a:rPr lang="en-US" sz="2000" dirty="0">
                 <a:solidFill>
                   <a:srgbClr val="141B26"/>
                 </a:solidFill>
               </a:rPr>
               <a:t>I can describe abiotic and biotic environmental factors and give examples of environmental variation.</a:t>
             </a:r>
-            <a:endParaRPr lang="en-US" sz="1600" dirty="0"/>
+            <a:endParaRPr lang="en-US" sz="2000" dirty="0"/>
           </a:p>
         </p:txBody>
       </p:sp>
@@ -5423,8 +5397,8 @@
         </p:nvSpPr>
         <p:spPr>
           <a:xfrm>
-            <a:off x="594360" y="2907792"/>
-            <a:ext cx="292608" cy="292608"/>
+            <a:off x="594360" y="2679192"/>
+            <a:ext cx="310896" cy="310896"/>
           </a:xfrm>
           <a:prstGeom prst="rect">
             <a:avLst/>
@@ -5448,33 +5422,31 @@
         </p:nvSpPr>
         <p:spPr>
           <a:xfrm>
-            <a:off x="1051560" y="2834640"/>
-            <a:ext cx="5120640" cy="868680"/>
-          </a:xfrm>
-          <a:prstGeom prst="rect">
-            <a:avLst/>
-          </a:prstGeom>
-          <a:noFill/>
-          <a:ln/>
-        </p:spPr>
-        <p:txBody>
-          <a:bodyPr wrap="square" lIns="0" tIns="0" rIns="0" bIns="0" rtlCol="0" anchor="t">
-            <a:normAutofit/>
-          </a:bodyPr>
+            <a:off x="1097280" y="2606040"/>
+            <a:ext cx="10332720" cy="868680"/>
+          </a:xfrm>
+          <a:prstGeom prst="rect">
+            <a:avLst/>
+          </a:prstGeom>
+          <a:noFill/>
+          <a:ln/>
+        </p:spPr>
+        <p:txBody>
+          <a:bodyPr wrap="square" lIns="0" tIns="0" rIns="0" bIns="0" rtlCol="0" anchor="t"/>
           <a:lstStyle/>
           <a:p>
             <a:pPr indent="0" marL="0">
               <a:buNone/>
             </a:pPr>
             <a:r>
-              <a:rPr lang="en-US" sz="1600" dirty="0">
+              <a:rPr lang="en-US" sz="2000" dirty="0">
                 <a:solidFill>
                   <a:srgbClr val="141B26"/>
                 </a:solidFill>
               </a:rPr>
               <a:t>I can tell continuous variation from discontinuous variation, and explain why environmental variation can make classification difficult.</a:t>
             </a:r>
-            <a:endParaRPr lang="en-US" sz="1600" dirty="0"/>
+            <a:endParaRPr lang="en-US" sz="2000" dirty="0"/>
           </a:p>
         </p:txBody>
       </p:sp>
@@ -5486,8 +5458,8 @@
         </p:nvSpPr>
         <p:spPr>
           <a:xfrm>
-            <a:off x="6583680" y="1325880"/>
-            <a:ext cx="5029200" cy="457200"/>
+            <a:off x="548640" y="3611880"/>
+            <a:ext cx="5486400" cy="411480"/>
           </a:xfrm>
           <a:prstGeom prst="rect">
             <a:avLst/>
@@ -5503,14 +5475,14 @@
               <a:buNone/>
             </a:pPr>
             <a:r>
-              <a:rPr lang="en-US" sz="2000" b="1" dirty="0">
+              <a:rPr lang="en-US" sz="2200" b="1" dirty="0">
                 <a:solidFill>
                   <a:srgbClr val="7B3A8E"/>
                 </a:solidFill>
               </a:rPr>
               <a:t>Key words today</a:t>
             </a:r>
-            <a:endParaRPr lang="en-US" sz="2000" dirty="0"/>
+            <a:endParaRPr lang="en-US" sz="2200" dirty="0"/>
           </a:p>
         </p:txBody>
       </p:sp>
@@ -5522,360 +5494,295 @@
         </p:nvSpPr>
         <p:spPr>
           <a:xfrm>
-            <a:off x="6583680" y="1874520"/>
-            <a:ext cx="5029200" cy="4023360"/>
-          </a:xfrm>
-          <a:prstGeom prst="rect">
-            <a:avLst/>
-          </a:prstGeom>
-          <a:noFill/>
-          <a:ln/>
-        </p:spPr>
-        <p:txBody>
-          <a:bodyPr wrap="square" lIns="0" tIns="0" rIns="0" bIns="0" rtlCol="0" anchor="t">
-            <a:normAutofit/>
-          </a:bodyPr>
+            <a:off x="548640" y="4069080"/>
+            <a:ext cx="3515258" cy="1920240"/>
+          </a:xfrm>
+          <a:prstGeom prst="rect">
+            <a:avLst/>
+          </a:prstGeom>
+          <a:noFill/>
+          <a:ln/>
+        </p:spPr>
+        <p:txBody>
+          <a:bodyPr wrap="square" lIns="0" tIns="0" rIns="0" bIns="0" rtlCol="0" anchor="t"/>
+          <a:lstStyle/>
+          <a:p>
+            <a:pPr marL="304800" indent="-304800">
+              <a:spcAft>
+                <a:spcPts val="600"/>
+              </a:spcAft>
+              <a:buSzPct val="100000"/>
+              <a:buChar char="•"/>
+            </a:pPr>
+            <a:r>
+              <a:rPr lang="en-US" sz="2100" b="1" dirty="0">
+                <a:solidFill>
+                  <a:srgbClr val="0F2A5F"/>
+                </a:solidFill>
+              </a:rPr>
+              <a:t>species</a:t>
+            </a:r>
+            <a:endParaRPr lang="en-US" sz="2100" dirty="0"/>
+          </a:p>
+          <a:p>
+            <a:pPr marL="304800" indent="-304800">
+              <a:spcAft>
+                <a:spcPts val="600"/>
+              </a:spcAft>
+              <a:buSzPct val="100000"/>
+              <a:buChar char="•"/>
+            </a:pPr>
+            <a:r>
+              <a:rPr lang="en-US" sz="2100" b="1" dirty="0">
+                <a:solidFill>
+                  <a:srgbClr val="0F2A5F"/>
+                </a:solidFill>
+              </a:rPr>
+              <a:t>extinct</a:t>
+            </a:r>
+            <a:endParaRPr lang="en-US" sz="2100" dirty="0"/>
+          </a:p>
+          <a:p>
+            <a:pPr marL="304800" indent="-304800">
+              <a:spcAft>
+                <a:spcPts val="600"/>
+              </a:spcAft>
+              <a:buSzPct val="100000"/>
+              <a:buChar char="•"/>
+            </a:pPr>
+            <a:r>
+              <a:rPr lang="en-US" sz="2100" b="1" dirty="0">
+                <a:solidFill>
+                  <a:srgbClr val="0F2A5F"/>
+                </a:solidFill>
+              </a:rPr>
+              <a:t>environment</a:t>
+            </a:r>
+            <a:endParaRPr lang="en-US" sz="2100" dirty="0"/>
+          </a:p>
+          <a:p>
+            <a:pPr marL="304800" indent="-304800">
+              <a:spcAft>
+                <a:spcPts val="600"/>
+              </a:spcAft>
+              <a:buSzPct val="100000"/>
+              <a:buChar char="•"/>
+            </a:pPr>
+            <a:r>
+              <a:rPr lang="en-US" sz="2100" b="1" dirty="0">
+                <a:solidFill>
+                  <a:srgbClr val="0F2A5F"/>
+                </a:solidFill>
+              </a:rPr>
+              <a:t>abiotic factor</a:t>
+            </a:r>
+            <a:endParaRPr lang="en-US" sz="2100" dirty="0"/>
+          </a:p>
+        </p:txBody>
+      </p:sp>
+      <p:sp>
+        <p:nvSpPr>
+          <p:cNvPr id="12" name="Text 10"/>
+          <p:cNvSpPr txBox="1"/>
+          <p:nvPr/>
+        </p:nvSpPr>
+        <p:spPr>
+          <a:xfrm>
+            <a:off x="4338218" y="4069080"/>
+            <a:ext cx="3515258" cy="1920240"/>
+          </a:xfrm>
+          <a:prstGeom prst="rect">
+            <a:avLst/>
+          </a:prstGeom>
+          <a:noFill/>
+          <a:ln/>
+        </p:spPr>
+        <p:txBody>
+          <a:bodyPr wrap="square" lIns="0" tIns="0" rIns="0" bIns="0" rtlCol="0" anchor="t"/>
+          <a:lstStyle/>
+          <a:p>
+            <a:pPr marL="304800" indent="-304800">
+              <a:spcAft>
+                <a:spcPts val="600"/>
+              </a:spcAft>
+              <a:buSzPct val="100000"/>
+              <a:buChar char="•"/>
+            </a:pPr>
+            <a:r>
+              <a:rPr lang="en-US" sz="2100" b="1" dirty="0">
+                <a:solidFill>
+                  <a:srgbClr val="0F2A5F"/>
+                </a:solidFill>
+              </a:rPr>
+              <a:t>biotic factor</a:t>
+            </a:r>
+            <a:endParaRPr lang="en-US" sz="2100" dirty="0"/>
+          </a:p>
+          <a:p>
+            <a:pPr marL="304800" indent="-304800">
+              <a:spcAft>
+                <a:spcPts val="600"/>
+              </a:spcAft>
+              <a:buSzPct val="100000"/>
+              <a:buChar char="•"/>
+            </a:pPr>
+            <a:r>
+              <a:rPr lang="en-US" sz="2100" b="1" dirty="0">
+                <a:solidFill>
+                  <a:srgbClr val="0F2A5F"/>
+                </a:solidFill>
+              </a:rPr>
+              <a:t>characteristic</a:t>
+            </a:r>
+            <a:endParaRPr lang="en-US" sz="2100" dirty="0"/>
+          </a:p>
+          <a:p>
+            <a:pPr marL="304800" indent="-304800">
+              <a:spcAft>
+                <a:spcPts val="600"/>
+              </a:spcAft>
+              <a:buSzPct val="100000"/>
+              <a:buChar char="•"/>
+            </a:pPr>
+            <a:r>
+              <a:rPr lang="en-US" sz="2100" b="1" dirty="0">
+                <a:solidFill>
+                  <a:srgbClr val="0F2A5F"/>
+                </a:solidFill>
+              </a:rPr>
+              <a:t>variation</a:t>
+            </a:r>
+            <a:endParaRPr lang="en-US" sz="2100" dirty="0"/>
+          </a:p>
+          <a:p>
+            <a:pPr marL="304800" indent="-304800">
+              <a:spcAft>
+                <a:spcPts val="600"/>
+              </a:spcAft>
+              <a:buSzPct val="100000"/>
+              <a:buChar char="•"/>
+            </a:pPr>
+            <a:r>
+              <a:rPr lang="en-US" sz="2100" b="1" dirty="0">
+                <a:solidFill>
+                  <a:srgbClr val="0F2A5F"/>
+                </a:solidFill>
+              </a:rPr>
+              <a:t>environmental variation</a:t>
+            </a:r>
+            <a:endParaRPr lang="en-US" sz="2100" dirty="0"/>
+          </a:p>
+        </p:txBody>
+      </p:sp>
+      <p:sp>
+        <p:nvSpPr>
+          <p:cNvPr id="13" name="Text 11"/>
+          <p:cNvSpPr txBox="1"/>
+          <p:nvPr/>
+        </p:nvSpPr>
+        <p:spPr>
+          <a:xfrm>
+            <a:off x="8127797" y="4069080"/>
+            <a:ext cx="3515258" cy="1920240"/>
+          </a:xfrm>
+          <a:prstGeom prst="rect">
+            <a:avLst/>
+          </a:prstGeom>
+          <a:noFill/>
+          <a:ln/>
+        </p:spPr>
+        <p:txBody>
+          <a:bodyPr wrap="square" lIns="0" tIns="0" rIns="0" bIns="0" rtlCol="0" anchor="t"/>
+          <a:lstStyle/>
+          <a:p>
+            <a:pPr marL="304800" indent="-304800">
+              <a:spcAft>
+                <a:spcPts val="600"/>
+              </a:spcAft>
+              <a:buSzPct val="100000"/>
+              <a:buChar char="•"/>
+            </a:pPr>
+            <a:r>
+              <a:rPr lang="en-US" sz="2200" b="1" dirty="0">
+                <a:solidFill>
+                  <a:srgbClr val="0F2A5F"/>
+                </a:solidFill>
+              </a:rPr>
+              <a:t>continuous variation</a:t>
+            </a:r>
+            <a:endParaRPr lang="en-US" sz="2200" dirty="0"/>
+          </a:p>
+          <a:p>
+            <a:pPr marL="304800" indent="-304800">
+              <a:spcAft>
+                <a:spcPts val="600"/>
+              </a:spcAft>
+              <a:buSzPct val="100000"/>
+              <a:buChar char="•"/>
+            </a:pPr>
+            <a:r>
+              <a:rPr lang="en-US" sz="2200" b="1" dirty="0">
+                <a:solidFill>
+                  <a:srgbClr val="0F2A5F"/>
+                </a:solidFill>
+              </a:rPr>
+              <a:t>discontinuous variation</a:t>
+            </a:r>
+            <a:endParaRPr lang="en-US" sz="2200" dirty="0"/>
+          </a:p>
+          <a:p>
+            <a:pPr marL="304800" indent="-304800">
+              <a:spcAft>
+                <a:spcPts val="600"/>
+              </a:spcAft>
+              <a:buSzPct val="100000"/>
+              <a:buChar char="•"/>
+            </a:pPr>
+            <a:r>
+              <a:rPr lang="en-US" sz="2200" b="1" dirty="0">
+                <a:solidFill>
+                  <a:srgbClr val="0F2A5F"/>
+                </a:solidFill>
+              </a:rPr>
+              <a:t>classification</a:t>
+            </a:r>
+            <a:endParaRPr lang="en-US" sz="2200" dirty="0"/>
+          </a:p>
+        </p:txBody>
+      </p:sp>
+      <p:sp>
+        <p:nvSpPr>
+          <p:cNvPr id="14" name="Text 12"/>
+          <p:cNvSpPr txBox="1"/>
+          <p:nvPr/>
+        </p:nvSpPr>
+        <p:spPr>
+          <a:xfrm>
+            <a:off x="548640" y="6035040"/>
+            <a:ext cx="10881360" cy="320040"/>
+          </a:xfrm>
+          <a:prstGeom prst="rect">
+            <a:avLst/>
+          </a:prstGeom>
+          <a:noFill/>
+          <a:ln/>
+        </p:spPr>
+        <p:txBody>
+          <a:bodyPr wrap="square" lIns="0" tIns="0" rIns="0" bIns="0" rtlCol="0" anchor="ctr"/>
           <a:lstStyle/>
           <a:p>
             <a:pPr indent="0" marL="0">
-              <a:spcAft>
-                <a:spcPts val="500"/>
-              </a:spcAft>
-              <a:buNone/>
-            </a:pPr>
-            <a:r>
-              <a:rPr lang="en-US" sz="1300" b="1" dirty="0">
-                <a:solidFill>
-                  <a:srgbClr val="0F2A5F"/>
-                </a:solidFill>
-              </a:rPr>
-              <a:t>species</a:t>
-            </a:r>
-            <a:pPr indent="0" marL="0">
-              <a:spcAft>
-                <a:spcPts val="500"/>
-              </a:spcAft>
-              <a:buNone/>
-            </a:pPr>
-            <a:r>
-              <a:rPr lang="en-US" sz="1300" dirty="0">
-                <a:solidFill>
-                  <a:srgbClr val="141B26"/>
-                </a:solidFill>
-              </a:rPr>
-              <a:t>  a group of organisms that can breed together to produce offspring that can also breed</a:t>
-            </a:r>
-            <a:endParaRPr lang="en-US" sz="1300" dirty="0"/>
-          </a:p>
-          <a:p>
-            <a:pPr indent="0" marL="0">
-              <a:spcAft>
-                <a:spcPts val="500"/>
-              </a:spcAft>
-              <a:buNone/>
-            </a:pPr>
-            <a:r>
-              <a:rPr lang="en-US" sz="1300" b="1" dirty="0">
-                <a:solidFill>
-                  <a:srgbClr val="0F2A5F"/>
-                </a:solidFill>
-              </a:rPr>
-              <a:t>extinct</a:t>
-            </a:r>
-            <a:pPr indent="0" marL="0">
-              <a:spcAft>
-                <a:spcPts val="500"/>
-              </a:spcAft>
-              <a:buNone/>
-            </a:pPr>
-            <a:r>
-              <a:rPr lang="en-US" sz="1300" dirty="0">
-                <a:solidFill>
-                  <a:srgbClr val="141B26"/>
-                </a:solidFill>
-              </a:rPr>
-              <a:t>  a species with no living members left</a:t>
-            </a:r>
-            <a:endParaRPr lang="en-US" sz="1300" dirty="0"/>
-          </a:p>
-          <a:p>
-            <a:pPr indent="0" marL="0">
-              <a:spcAft>
-                <a:spcPts val="500"/>
-              </a:spcAft>
-              <a:buNone/>
-            </a:pPr>
-            <a:r>
-              <a:rPr lang="en-US" sz="1300" b="1" dirty="0">
-                <a:solidFill>
-                  <a:srgbClr val="0F2A5F"/>
-                </a:solidFill>
-              </a:rPr>
-              <a:t>environment</a:t>
-            </a:r>
-            <a:pPr indent="0" marL="0">
-              <a:spcAft>
-                <a:spcPts val="500"/>
-              </a:spcAft>
-              <a:buNone/>
-            </a:pPr>
-            <a:r>
-              <a:rPr lang="en-US" sz="1300" dirty="0">
-                <a:solidFill>
-                  <a:srgbClr val="141B26"/>
-                </a:solidFill>
-              </a:rPr>
-              <a:t>  the surroundings of an organism</a:t>
-            </a:r>
-            <a:endParaRPr lang="en-US" sz="1300" dirty="0"/>
-          </a:p>
-          <a:p>
-            <a:pPr indent="0" marL="0">
-              <a:spcAft>
-                <a:spcPts val="500"/>
-              </a:spcAft>
-              <a:buNone/>
-            </a:pPr>
-            <a:r>
-              <a:rPr lang="en-US" sz="1300" b="1" dirty="0">
-                <a:solidFill>
-                  <a:srgbClr val="0F2A5F"/>
-                </a:solidFill>
-              </a:rPr>
-              <a:t>abiotic factor</a:t>
-            </a:r>
-            <a:pPr indent="0" marL="0">
-              <a:spcAft>
-                <a:spcPts val="500"/>
-              </a:spcAft>
-              <a:buNone/>
-            </a:pPr>
-            <a:r>
-              <a:rPr lang="en-US" sz="1300" dirty="0">
-                <a:solidFill>
-                  <a:srgbClr val="141B26"/>
-                </a:solidFill>
-              </a:rPr>
-              <a:t>  a physical (non-living) part of the environment, e.g. temperature</a:t>
-            </a:r>
-            <a:endParaRPr lang="en-US" sz="1300" dirty="0"/>
-          </a:p>
-          <a:p>
-            <a:pPr indent="0" marL="0">
-              <a:spcAft>
-                <a:spcPts val="500"/>
-              </a:spcAft>
-              <a:buNone/>
-            </a:pPr>
-            <a:r>
-              <a:rPr lang="en-US" sz="1300" b="1" dirty="0">
-                <a:solidFill>
-                  <a:srgbClr val="0F2A5F"/>
-                </a:solidFill>
-              </a:rPr>
-              <a:t>biotic factor</a:t>
-            </a:r>
-            <a:pPr indent="0" marL="0">
-              <a:spcAft>
-                <a:spcPts val="500"/>
-              </a:spcAft>
-              <a:buNone/>
-            </a:pPr>
-            <a:r>
-              <a:rPr lang="en-US" sz="1300" dirty="0">
-                <a:solidFill>
-                  <a:srgbClr val="141B26"/>
-                </a:solidFill>
-              </a:rPr>
-              <a:t>  the activities of other organisms, e.g. predation, disease</a:t>
-            </a:r>
-            <a:endParaRPr lang="en-US" sz="1300" dirty="0"/>
-          </a:p>
-          <a:p>
-            <a:pPr indent="0" marL="0">
-              <a:spcAft>
-                <a:spcPts val="500"/>
-              </a:spcAft>
-              <a:buNone/>
-            </a:pPr>
-            <a:r>
-              <a:rPr lang="en-US" sz="1300" b="1" dirty="0">
-                <a:solidFill>
-                  <a:srgbClr val="0F2A5F"/>
-                </a:solidFill>
-              </a:rPr>
-              <a:t>characteristic</a:t>
-            </a:r>
-            <a:pPr indent="0" marL="0">
-              <a:spcAft>
-                <a:spcPts val="500"/>
-              </a:spcAft>
-              <a:buNone/>
-            </a:pPr>
-            <a:r>
-              <a:rPr lang="en-US" sz="1300" dirty="0">
-                <a:solidFill>
-                  <a:srgbClr val="141B26"/>
-                </a:solidFill>
-              </a:rPr>
-              <a:t>  a feature of an organism</a:t>
-            </a:r>
-            <a:endParaRPr lang="en-US" sz="1300" dirty="0"/>
-          </a:p>
-          <a:p>
-            <a:pPr indent="0" marL="0">
-              <a:spcAft>
-                <a:spcPts val="500"/>
-              </a:spcAft>
-              <a:buNone/>
-            </a:pPr>
-            <a:r>
-              <a:rPr lang="en-US" sz="1300" b="1" dirty="0">
-                <a:solidFill>
-                  <a:srgbClr val="0F2A5F"/>
-                </a:solidFill>
-              </a:rPr>
-              <a:t>variation</a:t>
-            </a:r>
-            <a:pPr indent="0" marL="0">
-              <a:spcAft>
-                <a:spcPts val="500"/>
-              </a:spcAft>
-              <a:buNone/>
-            </a:pPr>
-            <a:r>
-              <a:rPr lang="en-US" sz="1300" dirty="0">
-                <a:solidFill>
-                  <a:srgbClr val="141B26"/>
-                </a:solidFill>
-              </a:rPr>
-              <a:t>  the differences between the characteristics of organisms</a:t>
-            </a:r>
-            <a:endParaRPr lang="en-US" sz="1300" dirty="0"/>
-          </a:p>
-          <a:p>
-            <a:pPr indent="0" marL="0">
-              <a:spcAft>
-                <a:spcPts val="500"/>
-              </a:spcAft>
-              <a:buNone/>
-            </a:pPr>
-            <a:r>
-              <a:rPr lang="en-US" sz="1300" b="1" dirty="0">
-                <a:solidFill>
-                  <a:srgbClr val="0F2A5F"/>
-                </a:solidFill>
-              </a:rPr>
-              <a:t>environmental variation</a:t>
-            </a:r>
-            <a:pPr indent="0" marL="0">
-              <a:spcAft>
-                <a:spcPts val="500"/>
-              </a:spcAft>
-              <a:buNone/>
-            </a:pPr>
-            <a:r>
-              <a:rPr lang="en-US" sz="1300" dirty="0">
-                <a:solidFill>
-                  <a:srgbClr val="141B26"/>
-                </a:solidFill>
-              </a:rPr>
-              <a:t>  variation caused by an organism's environment</a:t>
-            </a:r>
-            <a:endParaRPr lang="en-US" sz="1300" dirty="0"/>
-          </a:p>
-          <a:p>
-            <a:pPr indent="0" marL="0">
-              <a:spcAft>
-                <a:spcPts val="500"/>
-              </a:spcAft>
-              <a:buNone/>
-            </a:pPr>
-            <a:r>
-              <a:rPr lang="en-US" sz="1300" b="1" dirty="0">
-                <a:solidFill>
-                  <a:srgbClr val="0F2A5F"/>
-                </a:solidFill>
-              </a:rPr>
-              <a:t>continuous variation</a:t>
-            </a:r>
-            <a:pPr indent="0" marL="0">
-              <a:spcAft>
-                <a:spcPts val="500"/>
-              </a:spcAft>
-              <a:buNone/>
-            </a:pPr>
-            <a:r>
-              <a:rPr lang="en-US" sz="1300" dirty="0">
-                <a:solidFill>
-                  <a:srgbClr val="141B26"/>
-                </a:solidFill>
-              </a:rPr>
-              <a:t>  variation that can have any value between two points</a:t>
-            </a:r>
-            <a:endParaRPr lang="en-US" sz="1300" dirty="0"/>
-          </a:p>
-          <a:p>
-            <a:pPr indent="0" marL="0">
-              <a:spcAft>
-                <a:spcPts val="500"/>
-              </a:spcAft>
-              <a:buNone/>
-            </a:pPr>
-            <a:r>
-              <a:rPr lang="en-US" sz="1300" b="1" dirty="0">
-                <a:solidFill>
-                  <a:srgbClr val="0F2A5F"/>
-                </a:solidFill>
-              </a:rPr>
-              <a:t>discontinuous variation</a:t>
-            </a:r>
-            <a:pPr indent="0" marL="0">
-              <a:spcAft>
-                <a:spcPts val="500"/>
-              </a:spcAft>
-              <a:buNone/>
-            </a:pPr>
-            <a:r>
-              <a:rPr lang="en-US" sz="1300" dirty="0">
-                <a:solidFill>
-                  <a:srgbClr val="141B26"/>
-                </a:solidFill>
-              </a:rPr>
-              <a:t>  variation with only a limited set of possible values</a:t>
-            </a:r>
-            <a:endParaRPr lang="en-US" sz="1300" dirty="0"/>
-          </a:p>
-          <a:p>
-            <a:pPr indent="0" marL="0">
-              <a:spcAft>
-                <a:spcPts val="500"/>
-              </a:spcAft>
-              <a:buNone/>
-            </a:pPr>
-            <a:r>
-              <a:rPr lang="en-US" sz="1300" b="1" dirty="0">
-                <a:solidFill>
-                  <a:srgbClr val="0F2A5F"/>
-                </a:solidFill>
-              </a:rPr>
-              <a:t>classification</a:t>
-            </a:r>
-            <a:pPr indent="0" marL="0">
-              <a:spcAft>
-                <a:spcPts val="500"/>
-              </a:spcAft>
-              <a:buNone/>
-            </a:pPr>
-            <a:r>
-              <a:rPr lang="en-US" sz="1300" dirty="0">
-                <a:solidFill>
-                  <a:srgbClr val="141B26"/>
-                </a:solidFill>
-              </a:rPr>
-              <a:t>  sorting organisms into groups</a:t>
-            </a:r>
-            <a:endParaRPr lang="en-US" sz="1300" dirty="0"/>
+              <a:buNone/>
+            </a:pPr>
+            <a:r>
+              <a:rPr lang="en-US" sz="1400" i="1" dirty="0">
+                <a:solidFill>
+                  <a:srgbClr val="5B6574"/>
+                </a:solidFill>
+              </a:rPr>
+              <a:t>Meanings are in the key words box on your worksheet.</a:t>
+            </a:r>
+            <a:endParaRPr lang="en-US" sz="1400" dirty="0"/>
           </a:p>
         </p:txBody>
       </p:sp>
@@ -6059,32 +5966,30 @@
         <p:spPr>
           <a:xfrm>
             <a:off x="548640" y="1371600"/>
-            <a:ext cx="5394960" cy="2377440"/>
-          </a:xfrm>
-          <a:prstGeom prst="rect">
-            <a:avLst/>
-          </a:prstGeom>
-          <a:noFill/>
-          <a:ln/>
-        </p:spPr>
-        <p:txBody>
-          <a:bodyPr wrap="square" lIns="0" tIns="0" rIns="0" bIns="0" rtlCol="0" anchor="t">
-            <a:normAutofit/>
-          </a:bodyPr>
+            <a:ext cx="5394960" cy="2651760"/>
+          </a:xfrm>
+          <a:prstGeom prst="rect">
+            <a:avLst/>
+          </a:prstGeom>
+          <a:noFill/>
+          <a:ln/>
+        </p:spPr>
+        <p:txBody>
+          <a:bodyPr wrap="square" lIns="0" tIns="0" rIns="0" bIns="0" rtlCol="0" anchor="t"/>
           <a:lstStyle/>
           <a:p>
             <a:pPr indent="0" marL="0">
               <a:buNone/>
             </a:pPr>
             <a:r>
-              <a:rPr lang="en-US" sz="2800" b="1" dirty="0">
+              <a:rPr lang="en-US" sz="3000" b="1" dirty="0">
                 <a:solidFill>
                   <a:srgbClr val="0F2A5F"/>
                 </a:solidFill>
               </a:rPr>
               <a:t>These pumpkins can have a mass of over 1000 kg. They did not get this big by chance. What did the growers give the plants?</a:t>
             </a:r>
-            <a:endParaRPr lang="en-US" sz="2800" dirty="0"/>
+            <a:endParaRPr lang="en-US" sz="3000" dirty="0"/>
           </a:p>
         </p:txBody>
       </p:sp>
@@ -6096,19 +6001,17 @@
         </p:nvSpPr>
         <p:spPr>
           <a:xfrm>
-            <a:off x="548640" y="3794760"/>
-            <a:ext cx="5394960" cy="2103120"/>
-          </a:xfrm>
-          <a:prstGeom prst="rect">
-            <a:avLst/>
-          </a:prstGeom>
-          <a:noFill/>
-          <a:ln/>
-        </p:spPr>
-        <p:txBody>
-          <a:bodyPr wrap="square" lIns="0" tIns="0" rIns="0" bIns="0" rtlCol="0" anchor="t">
-            <a:normAutofit/>
-          </a:bodyPr>
+            <a:off x="548640" y="4114800"/>
+            <a:ext cx="5394960" cy="1828800"/>
+          </a:xfrm>
+          <a:prstGeom prst="rect">
+            <a:avLst/>
+          </a:prstGeom>
+          <a:noFill/>
+          <a:ln/>
+        </p:spPr>
+        <p:txBody>
+          <a:bodyPr wrap="square" lIns="0" tIns="0" rIns="0" bIns="0" rtlCol="0" anchor="t"/>
           <a:lstStyle/>
           <a:p>
             <a:pPr indent="0" marL="0">
@@ -6118,14 +6021,14 @@
               <a:buNone/>
             </a:pPr>
             <a:r>
-              <a:rPr lang="en-US" sz="1600" dirty="0">
+              <a:rPr lang="en-US" sz="2000" dirty="0">
                 <a:solidFill>
                   <a:srgbClr val="141B26"/>
                 </a:solidFill>
               </a:rPr>
               <a:t>Talk to a partner for one minute. Make a list.</a:t>
             </a:r>
-            <a:endParaRPr lang="en-US" sz="1600" dirty="0"/>
+            <a:endParaRPr lang="en-US" sz="2000" dirty="0"/>
           </a:p>
         </p:txBody>
       </p:sp>
@@ -6162,7 +6065,7 @@
         <p:spPr>
           <a:xfrm>
             <a:off x="6309360" y="5532120"/>
-            <a:ext cx="5303520" cy="502920"/>
+            <a:ext cx="5303520" cy="548640"/>
           </a:xfrm>
           <a:prstGeom prst="rect">
             <a:avLst/>
@@ -6178,7 +6081,7 @@
               <a:buNone/>
             </a:pPr>
             <a:r>
-              <a:rPr lang="en-US" sz="1100" dirty="0">
+              <a:rPr lang="en-US" sz="1300" dirty="0">
                 <a:solidFill>
                   <a:srgbClr val="141B26"/>
                 </a:solidFill>
@@ -6188,21 +6091,21 @@
             <a:pPr algn="l" indent="0" marL="0">
               <a:buNone/>
             </a:pPr>
-            <a:endParaRPr lang="en-US" sz="1100" dirty="0"/>
+            <a:endParaRPr lang="en-US" sz="1300" dirty="0"/>
           </a:p>
           <a:p>
             <a:pPr algn="l" indent="0" marL="0">
               <a:buNone/>
             </a:pPr>
             <a:r>
-              <a:rPr lang="en-US" sz="800" dirty="0">
+              <a:rPr lang="en-US" sz="900" dirty="0">
                 <a:solidFill>
                   <a:srgbClr val="5B6574"/>
                 </a:solidFill>
               </a:rPr>
               <a:t>Image: Me in ME, CC BY 2.0, via Wikimedia Commons</a:t>
             </a:r>
-            <a:endParaRPr lang="en-US" sz="1100" dirty="0"/>
+            <a:endParaRPr lang="en-US" sz="1300" dirty="0"/>
           </a:p>
         </p:txBody>
       </p:sp>
@@ -6385,8 +6288,8 @@
         </p:nvSpPr>
         <p:spPr>
           <a:xfrm>
-            <a:off x="548640" y="6053328"/>
-            <a:ext cx="9601200" cy="292608"/>
+            <a:off x="548640" y="6035040"/>
+            <a:ext cx="9601200" cy="310896"/>
           </a:xfrm>
           <a:prstGeom prst="rect">
             <a:avLst/>
@@ -6402,7 +6305,7 @@
               <a:buNone/>
             </a:pPr>
             <a:r>
-              <a:rPr lang="en-US" sz="1200" b="1" dirty="0">
+              <a:rPr lang="en-US" sz="1400" b="1" dirty="0">
                 <a:solidFill>
                   <a:srgbClr val="7B3A8E"/>
                 </a:solidFill>
@@ -6413,14 +6316,14 @@
               <a:buNone/>
             </a:pPr>
             <a:r>
-              <a:rPr lang="en-US" sz="1200" dirty="0">
+              <a:rPr lang="en-US" sz="1400" dirty="0">
                 <a:solidFill>
                   <a:srgbClr val="7B3A8E"/>
                 </a:solidFill>
               </a:rPr>
               <a:t>environment   ·   abiotic factor   ·   biotic factor</a:t>
             </a:r>
-            <a:endParaRPr lang="en-US" sz="1200" dirty="0"/>
+            <a:endParaRPr lang="en-US" sz="1400" dirty="0"/>
           </a:p>
         </p:txBody>
       </p:sp>
@@ -6442,81 +6345,79 @@
           <a:ln/>
         </p:spPr>
         <p:txBody>
-          <a:bodyPr wrap="square" lIns="0" tIns="0" rIns="0" bIns="0" rtlCol="0" anchor="t">
-            <a:normAutofit/>
-          </a:bodyPr>
-          <a:lstStyle/>
-          <a:p>
-            <a:pPr marL="228600" indent="-228600">
+          <a:bodyPr wrap="square" lIns="0" tIns="0" rIns="0" bIns="0" rtlCol="0" anchor="t"/>
+          <a:lstStyle/>
+          <a:p>
+            <a:pPr marL="304800" indent="-304800">
               <a:spcAft>
-                <a:spcPts val="600"/>
+                <a:spcPts val="800"/>
               </a:spcAft>
               <a:buSzPct val="100000"/>
               <a:buChar char="•"/>
             </a:pPr>
             <a:r>
-              <a:rPr lang="en-US" sz="1600" dirty="0">
+              <a:rPr lang="en-US" sz="2000" dirty="0">
                 <a:solidFill>
                   <a:srgbClr val="141B26"/>
                 </a:solidFill>
               </a:rPr>
               <a:t>An organism's surroundings are its environment.</a:t>
             </a:r>
-            <a:endParaRPr lang="en-US" sz="1700" dirty="0"/>
-          </a:p>
-          <a:p>
-            <a:pPr marL="228600" indent="-228600">
+            <a:endParaRPr lang="en-US" sz="2000" dirty="0"/>
+          </a:p>
+          <a:p>
+            <a:pPr marL="304800" indent="-304800">
               <a:spcAft>
-                <a:spcPts val="600"/>
+                <a:spcPts val="800"/>
               </a:spcAft>
               <a:buSzPct val="100000"/>
               <a:buChar char="•"/>
             </a:pPr>
             <a:r>
-              <a:rPr lang="en-US" sz="1600" dirty="0">
+              <a:rPr lang="en-US" sz="2000" dirty="0">
                 <a:solidFill>
                   <a:srgbClr val="141B26"/>
                 </a:solidFill>
               </a:rPr>
               <a:t>Environmental factors can change an organism.</a:t>
             </a:r>
-            <a:endParaRPr lang="en-US" sz="1700" dirty="0"/>
-          </a:p>
-          <a:p>
-            <a:pPr marL="228600" indent="-228600">
+            <a:endParaRPr lang="en-US" sz="2000" dirty="0"/>
+          </a:p>
+          <a:p>
+            <a:pPr marL="304800" indent="-304800">
               <a:spcAft>
-                <a:spcPts val="600"/>
+                <a:spcPts val="800"/>
               </a:spcAft>
               <a:buSzPct val="100000"/>
               <a:buChar char="•"/>
             </a:pPr>
             <a:r>
-              <a:rPr lang="en-US" sz="1600" dirty="0">
+              <a:rPr lang="en-US" sz="2000" dirty="0">
                 <a:solidFill>
                   <a:srgbClr val="141B26"/>
                 </a:solidFill>
               </a:rPr>
               <a:t>Abiotic (physical) factors are non-living: temperature, light, water, mineral salts.</a:t>
             </a:r>
-            <a:endParaRPr lang="en-US" sz="1700" dirty="0"/>
-          </a:p>
-          <a:p>
-            <a:pPr marL="228600" indent="-228600">
+            <a:endParaRPr lang="en-US" sz="2000" dirty="0"/>
+          </a:p>
+          <a:p>
+            <a:pPr marL="304800" indent="-304800">
               <a:spcAft>
-                <a:spcPts val="600"/>
+                <a:spcPts val="800"/>
               </a:spcAft>
               <a:buSzPct val="100000"/>
               <a:buChar char="•"/>
             </a:pPr>
             <a:r>
-              <a:rPr lang="en-US" sz="1600" dirty="0">
+              <a:rPr lang="en-US" sz="2000" dirty="0">
                 <a:solidFill>
                   <a:srgbClr val="141B26"/>
                 </a:solidFill>
               </a:rPr>
               <a:t>Biotic factors are the activities of other organisms: competition, predation, infectious disease.</a:t>
             </a:r>
-            <a:endParaRPr lang="en-US" sz="1700" dirty="0"/>
+            <a:endParaRPr lang="en-US" sz="2000" dirty="0"/>
           </a:p>
         </p:txBody>
       </p:sp>
@@ -6587,16 +6488,14 @@
           <a:ln/>
         </p:spPr>
         <p:txBody>
-          <a:bodyPr wrap="square" lIns="0" tIns="0" rIns="0" bIns="0" rtlCol="0" anchor="ctr">
-            <a:normAutofit/>
-          </a:bodyPr>
+          <a:bodyPr wrap="square" lIns="0" tIns="0" rIns="0" bIns="0" rtlCol="0" anchor="ctr"/>
           <a:lstStyle/>
           <a:p>
             <a:pPr indent="0" marL="0">
               <a:buNone/>
             </a:pPr>
             <a:r>
-              <a:rPr lang="en-US" sz="1400" b="1" dirty="0">
+              <a:rPr lang="en-US" sz="1700" b="1" dirty="0">
                 <a:solidFill>
                   <a:srgbClr val="7B3A8E"/>
                 </a:solidFill>
@@ -6607,14 +6506,14 @@
               <a:buNone/>
             </a:pPr>
             <a:r>
-              <a:rPr lang="en-US" sz="1400" dirty="0">
+              <a:rPr lang="en-US" sz="1700" dirty="0">
                 <a:solidFill>
                   <a:srgbClr val="141B26"/>
                 </a:solidFill>
               </a:rPr>
               <a:t>Abiotic = non-living parts of the surroundings. Biotic = caused by other living things.</a:t>
             </a:r>
-            <a:endParaRPr lang="en-US" sz="1400" dirty="0"/>
+            <a:endParaRPr lang="en-US" sz="1700" dirty="0"/>
           </a:p>
         </p:txBody>
       </p:sp>
@@ -6797,8 +6696,8 @@
         </p:nvSpPr>
         <p:spPr>
           <a:xfrm>
-            <a:off x="548640" y="6053328"/>
-            <a:ext cx="9601200" cy="292608"/>
+            <a:off x="548640" y="6035040"/>
+            <a:ext cx="9601200" cy="310896"/>
           </a:xfrm>
           <a:prstGeom prst="rect">
             <a:avLst/>
@@ -6814,7 +6713,7 @@
               <a:buNone/>
             </a:pPr>
             <a:r>
-              <a:rPr lang="en-US" sz="1200" b="1" dirty="0">
+              <a:rPr lang="en-US" sz="1400" b="1" dirty="0">
                 <a:solidFill>
                   <a:srgbClr val="7B3A8E"/>
                 </a:solidFill>
@@ -6825,14 +6724,14 @@
               <a:buNone/>
             </a:pPr>
             <a:r>
-              <a:rPr lang="en-US" sz="1200" dirty="0">
+              <a:rPr lang="en-US" sz="1400" dirty="0">
                 <a:solidFill>
                   <a:srgbClr val="7B3A8E"/>
                 </a:solidFill>
               </a:rPr>
               <a:t>characteristic   ·   variation   ·   environmental variation</a:t>
             </a:r>
-            <a:endParaRPr lang="en-US" sz="1200" dirty="0"/>
+            <a:endParaRPr lang="en-US" sz="1400" dirty="0"/>
           </a:p>
         </p:txBody>
       </p:sp>
@@ -6854,81 +6753,79 @@
           <a:ln/>
         </p:spPr>
         <p:txBody>
-          <a:bodyPr wrap="square" lIns="0" tIns="0" rIns="0" bIns="0" rtlCol="0" anchor="t">
-            <a:normAutofit/>
-          </a:bodyPr>
-          <a:lstStyle/>
-          <a:p>
-            <a:pPr marL="228600" indent="-228600">
+          <a:bodyPr wrap="square" lIns="0" tIns="0" rIns="0" bIns="0" rtlCol="0" anchor="t"/>
+          <a:lstStyle/>
+          <a:p>
+            <a:pPr marL="304800" indent="-304800">
               <a:spcAft>
-                <a:spcPts val="600"/>
+                <a:spcPts val="800"/>
               </a:spcAft>
               <a:buSzPct val="100000"/>
               <a:buChar char="•"/>
             </a:pPr>
             <a:r>
-              <a:rPr lang="en-US" sz="1700" dirty="0">
+              <a:rPr lang="en-US" sz="2000" dirty="0">
                 <a:solidFill>
                   <a:srgbClr val="141B26"/>
                 </a:solidFill>
               </a:rPr>
               <a:t>The features of an organism are its characteristics.</a:t>
             </a:r>
-            <a:endParaRPr lang="en-US" sz="1700" dirty="0"/>
-          </a:p>
-          <a:p>
-            <a:pPr marL="228600" indent="-228600">
+            <a:endParaRPr lang="en-US" sz="2000" dirty="0"/>
+          </a:p>
+          <a:p>
+            <a:pPr marL="304800" indent="-304800">
               <a:spcAft>
-                <a:spcPts val="600"/>
+                <a:spcPts val="800"/>
               </a:spcAft>
               <a:buSzPct val="100000"/>
               <a:buChar char="•"/>
             </a:pPr>
             <a:r>
-              <a:rPr lang="en-US" sz="1700" dirty="0">
+              <a:rPr lang="en-US" sz="2000" dirty="0">
                 <a:solidFill>
                   <a:srgbClr val="141B26"/>
                 </a:solidFill>
               </a:rPr>
               <a:t>Variation is the difference between the characteristics of organisms.</a:t>
             </a:r>
-            <a:endParaRPr lang="en-US" sz="1700" dirty="0"/>
-          </a:p>
-          <a:p>
-            <a:pPr marL="228600" indent="-228600">
+            <a:endParaRPr lang="en-US" sz="2000" dirty="0"/>
+          </a:p>
+          <a:p>
+            <a:pPr marL="304800" indent="-304800">
               <a:spcAft>
-                <a:spcPts val="600"/>
+                <a:spcPts val="800"/>
               </a:spcAft>
               <a:buSzPct val="100000"/>
               <a:buChar char="•"/>
             </a:pPr>
             <a:r>
-              <a:rPr lang="en-US" sz="1700" dirty="0">
+              <a:rPr lang="en-US" sz="2000" dirty="0">
                 <a:solidFill>
                   <a:srgbClr val="141B26"/>
                 </a:solidFill>
               </a:rPr>
               <a:t>Environmental variation is caused by the environment.</a:t>
             </a:r>
-            <a:endParaRPr lang="en-US" sz="1700" dirty="0"/>
-          </a:p>
-          <a:p>
-            <a:pPr marL="228600" indent="-228600">
+            <a:endParaRPr lang="en-US" sz="2000" dirty="0"/>
+          </a:p>
+          <a:p>
+            <a:pPr marL="304800" indent="-304800">
               <a:spcAft>
-                <a:spcPts val="600"/>
+                <a:spcPts val="800"/>
               </a:spcAft>
               <a:buSzPct val="100000"/>
               <a:buChar char="•"/>
             </a:pPr>
             <a:r>
-              <a:rPr lang="en-US" sz="1700" dirty="0">
+              <a:rPr lang="en-US" sz="2000" dirty="0">
                 <a:solidFill>
                   <a:srgbClr val="141B26"/>
                 </a:solidFill>
               </a:rPr>
               <a:t>Examples: a scar (caused by a sharp object), a hairstyle (fashion), a tree bent by the wind, a pale plant grown in the dark.</a:t>
             </a:r>
-            <a:endParaRPr lang="en-US" sz="1700" dirty="0"/>
+            <a:endParaRPr lang="en-US" sz="2000" dirty="0"/>
           </a:p>
         </p:txBody>
       </p:sp>
@@ -6965,7 +6862,7 @@
         <p:spPr>
           <a:xfrm>
             <a:off x="6583680" y="4826987"/>
-            <a:ext cx="5029200" cy="502920"/>
+            <a:ext cx="5029200" cy="548640"/>
           </a:xfrm>
           <a:prstGeom prst="rect">
             <a:avLst/>
@@ -6981,7 +6878,7 @@
               <a:buNone/>
             </a:pPr>
             <a:r>
-              <a:rPr lang="en-US" sz="1100" dirty="0">
+              <a:rPr lang="en-US" sz="1300" dirty="0">
                 <a:solidFill>
                   <a:srgbClr val="141B26"/>
                 </a:solidFill>
@@ -6991,21 +6888,21 @@
             <a:pPr algn="l" indent="0" marL="0">
               <a:buNone/>
             </a:pPr>
-            <a:endParaRPr lang="en-US" sz="1100" dirty="0"/>
+            <a:endParaRPr lang="en-US" sz="1300" dirty="0"/>
           </a:p>
           <a:p>
             <a:pPr algn="l" indent="0" marL="0">
               <a:buNone/>
             </a:pPr>
             <a:r>
-              <a:rPr lang="en-US" sz="800" dirty="0">
+              <a:rPr lang="en-US" sz="900" dirty="0">
                 <a:solidFill>
                   <a:srgbClr val="5B6574"/>
                 </a:solidFill>
               </a:rPr>
               <a:t>Image: brewbooks, CC BY-SA 2.0, via Wikimedia Commons</a:t>
             </a:r>
-            <a:endParaRPr lang="en-US" sz="1100" dirty="0"/>
+            <a:endParaRPr lang="en-US" sz="1300" dirty="0"/>
           </a:p>
         </p:txBody>
       </p:sp>
@@ -7052,16 +6949,14 @@
           <a:ln/>
         </p:spPr>
         <p:txBody>
-          <a:bodyPr wrap="square" lIns="0" tIns="0" rIns="0" bIns="0" rtlCol="0" anchor="ctr">
-            <a:normAutofit/>
-          </a:bodyPr>
+          <a:bodyPr wrap="square" lIns="0" tIns="0" rIns="0" bIns="0" rtlCol="0" anchor="ctr"/>
           <a:lstStyle/>
           <a:p>
             <a:pPr indent="0" marL="0">
               <a:buNone/>
             </a:pPr>
             <a:r>
-              <a:rPr lang="en-US" sz="1400" b="1" dirty="0">
+              <a:rPr lang="en-US" sz="1700" b="1" dirty="0">
                 <a:solidFill>
                   <a:srgbClr val="7B3A8E"/>
                 </a:solidFill>
@@ -7072,14 +6967,14 @@
               <a:buNone/>
             </a:pPr>
             <a:r>
-              <a:rPr lang="en-US" sz="1400" dirty="0">
+              <a:rPr lang="en-US" sz="1700" dirty="0">
                 <a:solidFill>
                   <a:srgbClr val="141B26"/>
                 </a:solidFill>
               </a:rPr>
               <a:t>Environmental variation is not passed on to offspring.</a:t>
             </a:r>
-            <a:endParaRPr lang="en-US" sz="1400" dirty="0"/>
+            <a:endParaRPr lang="en-US" sz="1700" dirty="0"/>
           </a:p>
         </p:txBody>
       </p:sp>
@@ -7262,8 +7157,8 @@
         </p:nvSpPr>
         <p:spPr>
           <a:xfrm>
-            <a:off x="548640" y="6053328"/>
-            <a:ext cx="9601200" cy="292608"/>
+            <a:off x="548640" y="6035040"/>
+            <a:ext cx="9601200" cy="310896"/>
           </a:xfrm>
           <a:prstGeom prst="rect">
             <a:avLst/>
@@ -7279,7 +7174,7 @@
               <a:buNone/>
             </a:pPr>
             <a:r>
-              <a:rPr lang="en-US" sz="1200" b="1" dirty="0">
+              <a:rPr lang="en-US" sz="1400" b="1" dirty="0">
                 <a:solidFill>
                   <a:srgbClr val="7B3A8E"/>
                 </a:solidFill>
@@ -7290,14 +7185,14 @@
               <a:buNone/>
             </a:pPr>
             <a:r>
-              <a:rPr lang="en-US" sz="1200" dirty="0">
+              <a:rPr lang="en-US" sz="1400" dirty="0">
                 <a:solidFill>
                   <a:srgbClr val="7B3A8E"/>
                 </a:solidFill>
               </a:rPr>
               <a:t>continuous variation   ·   discontinuous variation</a:t>
             </a:r>
-            <a:endParaRPr lang="en-US" sz="1200" dirty="0"/>
+            <a:endParaRPr lang="en-US" sz="1400" dirty="0"/>
           </a:p>
         </p:txBody>
       </p:sp>
@@ -7353,14 +7248,14 @@
               <a:buNone/>
             </a:pPr>
             <a:r>
-              <a:rPr lang="en-US" sz="2000" b="1" dirty="0">
+              <a:rPr lang="en-US" sz="2200" b="1" dirty="0">
                 <a:solidFill>
                   <a:srgbClr val="0F2A5F"/>
                 </a:solidFill>
               </a:rPr>
               <a:t>Continuous variation</a:t>
             </a:r>
-            <a:endParaRPr lang="en-US" sz="2000" dirty="0"/>
+            <a:endParaRPr lang="en-US" sz="2200" dirty="0"/>
           </a:p>
         </p:txBody>
       </p:sp>
@@ -7382,99 +7277,97 @@
           <a:ln/>
         </p:spPr>
         <p:txBody>
-          <a:bodyPr wrap="square" lIns="0" tIns="0" rIns="0" bIns="0" rtlCol="0" anchor="t">
-            <a:normAutofit/>
-          </a:bodyPr>
-          <a:lstStyle/>
-          <a:p>
-            <a:pPr marL="228600" indent="-228600">
+          <a:bodyPr wrap="square" lIns="0" tIns="0" rIns="0" bIns="0" rtlCol="0" anchor="t"/>
+          <a:lstStyle/>
+          <a:p>
+            <a:pPr marL="304800" indent="-304800">
               <a:spcAft>
-                <a:spcPts val="600"/>
+                <a:spcPts val="800"/>
               </a:spcAft>
               <a:buSzPct val="100000"/>
               <a:buChar char="•"/>
             </a:pPr>
             <a:r>
-              <a:rPr lang="en-US" sz="1500" dirty="0">
+              <a:rPr lang="en-US" sz="1800" dirty="0">
                 <a:solidFill>
                   <a:srgbClr val="141B26"/>
                 </a:solidFill>
               </a:rPr>
               <a:t>Can have any value between two points.</a:t>
             </a:r>
-            <a:endParaRPr lang="en-US" sz="1500" dirty="0"/>
-          </a:p>
-          <a:p>
-            <a:pPr marL="228600" indent="-228600">
+            <a:endParaRPr lang="en-US" sz="1800" dirty="0"/>
+          </a:p>
+          <a:p>
+            <a:pPr marL="304800" indent="-304800">
               <a:spcAft>
-                <a:spcPts val="600"/>
+                <a:spcPts val="800"/>
               </a:spcAft>
               <a:buSzPct val="100000"/>
               <a:buChar char="•"/>
             </a:pPr>
             <a:r>
-              <a:rPr lang="en-US" sz="1500" dirty="0">
+              <a:rPr lang="en-US" sz="1800" dirty="0">
                 <a:solidFill>
                   <a:srgbClr val="141B26"/>
                 </a:solidFill>
               </a:rPr>
               <a:t>Examples: height, mass, leaf length, pumpkin size.</a:t>
             </a:r>
-            <a:endParaRPr lang="en-US" sz="1500" dirty="0"/>
-          </a:p>
-          <a:p>
-            <a:pPr marL="228600" indent="-228600">
+            <a:endParaRPr lang="en-US" sz="1800" dirty="0"/>
+          </a:p>
+          <a:p>
+            <a:pPr marL="304800" indent="-304800">
               <a:spcAft>
-                <a:spcPts val="600"/>
+                <a:spcPts val="800"/>
               </a:spcAft>
               <a:buSzPct val="100000"/>
               <a:buChar char="•"/>
             </a:pPr>
             <a:r>
-              <a:rPr lang="en-US" sz="1500" dirty="0">
+              <a:rPr lang="en-US" sz="1800" dirty="0">
                 <a:solidFill>
                   <a:srgbClr val="141B26"/>
                 </a:solidFill>
               </a:rPr>
               <a:t>Put the measurements into groups.</a:t>
             </a:r>
-            <a:endParaRPr lang="en-US" sz="1500" dirty="0"/>
-          </a:p>
-          <a:p>
-            <a:pPr marL="228600" indent="-228600">
+            <a:endParaRPr lang="en-US" sz="1800" dirty="0"/>
+          </a:p>
+          <a:p>
+            <a:pPr marL="304800" indent="-304800">
               <a:spcAft>
-                <a:spcPts val="600"/>
+                <a:spcPts val="800"/>
               </a:spcAft>
               <a:buSzPct val="100000"/>
               <a:buChar char="•"/>
             </a:pPr>
             <a:r>
-              <a:rPr lang="en-US" sz="1500" dirty="0">
+              <a:rPr lang="en-US" sz="1800" dirty="0">
                 <a:solidFill>
                   <a:srgbClr val="141B26"/>
                 </a:solidFill>
               </a:rPr>
               <a:t>Bar chart with no gaps between the bars.</a:t>
             </a:r>
-            <a:endParaRPr lang="en-US" sz="1500" dirty="0"/>
-          </a:p>
-          <a:p>
-            <a:pPr marL="228600" indent="-228600">
+            <a:endParaRPr lang="en-US" sz="1800" dirty="0"/>
+          </a:p>
+          <a:p>
+            <a:pPr marL="304800" indent="-304800">
               <a:spcAft>
-                <a:spcPts val="600"/>
+                <a:spcPts val="800"/>
               </a:spcAft>
               <a:buSzPct val="100000"/>
               <a:buChar char="•"/>
             </a:pPr>
             <a:r>
-              <a:rPr lang="en-US" sz="1500" dirty="0">
+              <a:rPr lang="en-US" sz="1800" dirty="0">
                 <a:solidFill>
                   <a:srgbClr val="141B26"/>
                 </a:solidFill>
               </a:rPr>
               <a:t>Often gives a bell shape (a normal distribution).</a:t>
             </a:r>
-            <a:endParaRPr lang="en-US" sz="1500" dirty="0"/>
+            <a:endParaRPr lang="en-US" sz="1800" dirty="0"/>
           </a:p>
         </p:txBody>
       </p:sp>
@@ -7530,14 +7423,14 @@
               <a:buNone/>
             </a:pPr>
             <a:r>
-              <a:rPr lang="en-US" sz="2000" b="1" dirty="0">
+              <a:rPr lang="en-US" sz="2200" b="1" dirty="0">
                 <a:solidFill>
                   <a:srgbClr val="0F2A5F"/>
                 </a:solidFill>
               </a:rPr>
               <a:t>Discontinuous variation</a:t>
             </a:r>
-            <a:endParaRPr lang="en-US" sz="2000" dirty="0"/>
+            <a:endParaRPr lang="en-US" sz="2200" dirty="0"/>
           </a:p>
         </p:txBody>
       </p:sp>
@@ -7559,81 +7452,79 @@
           <a:ln/>
         </p:spPr>
         <p:txBody>
-          <a:bodyPr wrap="square" lIns="0" tIns="0" rIns="0" bIns="0" rtlCol="0" anchor="t">
-            <a:normAutofit/>
-          </a:bodyPr>
-          <a:lstStyle/>
-          <a:p>
-            <a:pPr marL="228600" indent="-228600">
+          <a:bodyPr wrap="square" lIns="0" tIns="0" rIns="0" bIns="0" rtlCol="0" anchor="t"/>
+          <a:lstStyle/>
+          <a:p>
+            <a:pPr marL="304800" indent="-304800">
               <a:spcAft>
-                <a:spcPts val="600"/>
+                <a:spcPts val="800"/>
               </a:spcAft>
               <a:buSzPct val="100000"/>
               <a:buChar char="•"/>
             </a:pPr>
             <a:r>
-              <a:rPr lang="en-US" sz="1500" dirty="0">
+              <a:rPr lang="en-US" sz="1800" dirty="0">
                 <a:solidFill>
                   <a:srgbClr val="141B26"/>
                 </a:solidFill>
               </a:rPr>
               <a:t>Only a limited set of values.</a:t>
             </a:r>
-            <a:endParaRPr lang="en-US" sz="1500" dirty="0"/>
-          </a:p>
-          <a:p>
-            <a:pPr marL="228600" indent="-228600">
+            <a:endParaRPr lang="en-US" sz="1800" dirty="0"/>
+          </a:p>
+          <a:p>
+            <a:pPr marL="304800" indent="-304800">
               <a:spcAft>
-                <a:spcPts val="600"/>
+                <a:spcPts val="800"/>
               </a:spcAft>
               <a:buSzPct val="100000"/>
               <a:buChar char="•"/>
             </a:pPr>
             <a:r>
-              <a:rPr lang="en-US" sz="1500" dirty="0">
+              <a:rPr lang="en-US" sz="1800" dirty="0">
                 <a:solidFill>
                   <a:srgbClr val="141B26"/>
                 </a:solidFill>
               </a:rPr>
               <a:t>Examples: blood group, scar or no scar, number of petals.</a:t>
             </a:r>
-            <a:endParaRPr lang="en-US" sz="1500" dirty="0"/>
-          </a:p>
-          <a:p>
-            <a:pPr marL="228600" indent="-228600">
+            <a:endParaRPr lang="en-US" sz="1800" dirty="0"/>
+          </a:p>
+          <a:p>
+            <a:pPr marL="304800" indent="-304800">
               <a:spcAft>
-                <a:spcPts val="600"/>
+                <a:spcPts val="800"/>
               </a:spcAft>
               <a:buSzPct val="100000"/>
               <a:buChar char="•"/>
             </a:pPr>
             <a:r>
-              <a:rPr lang="en-US" sz="1500" dirty="0">
+              <a:rPr lang="en-US" sz="1800" dirty="0">
                 <a:solidFill>
                   <a:srgbClr val="141B26"/>
                 </a:solidFill>
               </a:rPr>
               <a:t>Count how many in each group.</a:t>
             </a:r>
-            <a:endParaRPr lang="en-US" sz="1500" dirty="0"/>
-          </a:p>
-          <a:p>
-            <a:pPr marL="228600" indent="-228600">
+            <a:endParaRPr lang="en-US" sz="1800" dirty="0"/>
+          </a:p>
+          <a:p>
+            <a:pPr marL="304800" indent="-304800">
               <a:spcAft>
-                <a:spcPts val="600"/>
+                <a:spcPts val="800"/>
               </a:spcAft>
               <a:buSzPct val="100000"/>
               <a:buChar char="•"/>
             </a:pPr>
             <a:r>
-              <a:rPr lang="en-US" sz="1500" dirty="0">
+              <a:rPr lang="en-US" sz="1800" dirty="0">
                 <a:solidFill>
                   <a:srgbClr val="141B26"/>
                 </a:solidFill>
               </a:rPr>
               <a:t>Bar chart with gaps between the bars.</a:t>
             </a:r>
-            <a:endParaRPr lang="en-US" sz="1500" dirty="0"/>
+            <a:endParaRPr lang="en-US" sz="1800" dirty="0"/>
           </a:p>
         </p:txBody>
       </p:sp>
@@ -7680,16 +7571,14 @@
           <a:ln/>
         </p:spPr>
         <p:txBody>
-          <a:bodyPr wrap="square" lIns="0" tIns="0" rIns="0" bIns="0" rtlCol="0" anchor="ctr">
-            <a:normAutofit/>
-          </a:bodyPr>
+          <a:bodyPr wrap="square" lIns="0" tIns="0" rIns="0" bIns="0" rtlCol="0" anchor="ctr"/>
           <a:lstStyle/>
           <a:p>
             <a:pPr indent="0" marL="0">
               <a:buNone/>
             </a:pPr>
             <a:r>
-              <a:rPr lang="en-US" sz="1400" b="1" dirty="0">
+              <a:rPr lang="en-US" sz="1700" b="1" dirty="0">
                 <a:solidFill>
                   <a:srgbClr val="7B3A8E"/>
                 </a:solidFill>
@@ -7700,14 +7589,14 @@
               <a:buNone/>
             </a:pPr>
             <a:r>
-              <a:rPr lang="en-US" sz="1400" dirty="0">
+              <a:rPr lang="en-US" sz="1700" dirty="0">
                 <a:solidFill>
                   <a:srgbClr val="141B26"/>
                 </a:solidFill>
               </a:rPr>
               <a:t>Ask: could the value be anything in between? If yes, it is continuous.</a:t>
             </a:r>
-            <a:endParaRPr lang="en-US" sz="1400" dirty="0"/>
+            <a:endParaRPr lang="en-US" sz="1700" dirty="0"/>
           </a:p>
         </p:txBody>
       </p:sp>
@@ -7907,14 +7796,14 @@
               <a:buNone/>
             </a:pPr>
             <a:r>
-              <a:rPr lang="en-US" sz="1400" i="1" dirty="0">
+              <a:rPr lang="en-US" sz="1600" i="1" dirty="0">
                 <a:solidFill>
                   <a:srgbClr val="5B6574"/>
                 </a:solidFill>
               </a:rPr>
               <a:t>Mini whiteboards or fingers. One answer each, then we check.</a:t>
             </a:r>
-            <a:endParaRPr lang="en-US" sz="1400" dirty="0"/>
+            <a:endParaRPr lang="en-US" sz="1600" dirty="0"/>
           </a:p>
         </p:txBody>
       </p:sp>
@@ -7963,16 +7852,14 @@
           <a:ln/>
         </p:spPr>
         <p:txBody>
-          <a:bodyPr wrap="square" lIns="0" tIns="0" rIns="0" bIns="0" rtlCol="0" anchor="ctr">
-            <a:normAutofit/>
-          </a:bodyPr>
+          <a:bodyPr wrap="square" lIns="0" tIns="0" rIns="0" bIns="0" rtlCol="0" anchor="ctr"/>
           <a:lstStyle/>
           <a:p>
             <a:pPr indent="0" marL="0">
               <a:buNone/>
             </a:pPr>
             <a:r>
-              <a:rPr lang="en-US" sz="1600" b="1" dirty="0">
+              <a:rPr lang="en-US" sz="2000" b="1" dirty="0">
                 <a:solidFill>
                   <a:srgbClr val="7B3A8E"/>
                 </a:solidFill>
@@ -7983,14 +7870,14 @@
               <a:buNone/>
             </a:pPr>
             <a:r>
-              <a:rPr lang="en-US" sz="1600" dirty="0">
+              <a:rPr lang="en-US" sz="2000" dirty="0">
                 <a:solidFill>
                   <a:srgbClr val="141B26"/>
                 </a:solidFill>
               </a:rPr>
               <a:t>Temperature: abiotic or biotic factor?</a:t>
             </a:r>
-            <a:endParaRPr lang="en-US" sz="1600" dirty="0"/>
+            <a:endParaRPr lang="en-US" sz="2000" dirty="0"/>
           </a:p>
         </p:txBody>
       </p:sp>
@@ -8039,16 +7926,14 @@
           <a:ln/>
         </p:spPr>
         <p:txBody>
-          <a:bodyPr wrap="square" lIns="0" tIns="0" rIns="0" bIns="0" rtlCol="0" anchor="ctr">
-            <a:normAutofit/>
-          </a:bodyPr>
+          <a:bodyPr wrap="square" lIns="0" tIns="0" rIns="0" bIns="0" rtlCol="0" anchor="ctr"/>
           <a:lstStyle/>
           <a:p>
             <a:pPr indent="0" marL="0">
               <a:buNone/>
             </a:pPr>
             <a:r>
-              <a:rPr lang="en-US" sz="1600" b="1" dirty="0">
+              <a:rPr lang="en-US" sz="2000" b="1" dirty="0">
                 <a:solidFill>
                   <a:srgbClr val="7B3A8E"/>
                 </a:solidFill>
@@ -8059,14 +7944,14 @@
               <a:buNone/>
             </a:pPr>
             <a:r>
-              <a:rPr lang="en-US" sz="1600" dirty="0">
+              <a:rPr lang="en-US" sz="2000" dirty="0">
                 <a:solidFill>
                   <a:srgbClr val="141B26"/>
                 </a:solidFill>
               </a:rPr>
               <a:t>A scar on your hand: environmental or inherited variation?</a:t>
             </a:r>
-            <a:endParaRPr lang="en-US" sz="1600" dirty="0"/>
+            <a:endParaRPr lang="en-US" sz="2000" dirty="0"/>
           </a:p>
         </p:txBody>
       </p:sp>
@@ -8115,16 +8000,14 @@
           <a:ln/>
         </p:spPr>
         <p:txBody>
-          <a:bodyPr wrap="square" lIns="0" tIns="0" rIns="0" bIns="0" rtlCol="0" anchor="ctr">
-            <a:normAutofit/>
-          </a:bodyPr>
+          <a:bodyPr wrap="square" lIns="0" tIns="0" rIns="0" bIns="0" rtlCol="0" anchor="ctr"/>
           <a:lstStyle/>
           <a:p>
             <a:pPr indent="0" marL="0">
               <a:buNone/>
             </a:pPr>
             <a:r>
-              <a:rPr lang="en-US" sz="1600" b="1" dirty="0">
+              <a:rPr lang="en-US" sz="2000" b="1" dirty="0">
                 <a:solidFill>
                   <a:srgbClr val="7B3A8E"/>
                 </a:solidFill>
@@ -8135,14 +8018,14 @@
               <a:buNone/>
             </a:pPr>
             <a:r>
-              <a:rPr lang="en-US" sz="1600" dirty="0">
+              <a:rPr lang="en-US" sz="2000" dirty="0">
                 <a:solidFill>
                   <a:srgbClr val="141B26"/>
                 </a:solidFill>
               </a:rPr>
               <a:t>Hand span: continuous or discontinuous variation?</a:t>
             </a:r>
-            <a:endParaRPr lang="en-US" sz="1600" dirty="0"/>
+            <a:endParaRPr lang="en-US" sz="2000" dirty="0"/>
           </a:p>
         </p:txBody>
       </p:sp>
@@ -8191,16 +8074,14 @@
           <a:ln/>
         </p:spPr>
         <p:txBody>
-          <a:bodyPr wrap="square" lIns="0" tIns="0" rIns="0" bIns="0" rtlCol="0" anchor="ctr">
-            <a:normAutofit/>
-          </a:bodyPr>
+          <a:bodyPr wrap="square" lIns="0" tIns="0" rIns="0" bIns="0" rtlCol="0" anchor="ctr"/>
           <a:lstStyle/>
           <a:p>
             <a:pPr indent="0" marL="0">
               <a:buNone/>
             </a:pPr>
             <a:r>
-              <a:rPr lang="en-US" sz="1600" b="1" dirty="0">
+              <a:rPr lang="en-US" sz="2000" b="1" dirty="0">
                 <a:solidFill>
                   <a:srgbClr val="7B3A8E"/>
                 </a:solidFill>
@@ -8211,14 +8092,14 @@
               <a:buNone/>
             </a:pPr>
             <a:r>
-              <a:rPr lang="en-US" sz="1600" dirty="0">
+              <a:rPr lang="en-US" sz="2000" dirty="0">
                 <a:solidFill>
                   <a:srgbClr val="141B26"/>
                 </a:solidFill>
               </a:rPr>
               <a:t>Whether a person can roll their tongue: continuous or discontinuous?</a:t>
             </a:r>
-            <a:endParaRPr lang="en-US" sz="1600" dirty="0"/>
+            <a:endParaRPr lang="en-US" sz="2000" dirty="0"/>
           </a:p>
         </p:txBody>
       </p:sp>
@@ -8267,16 +8148,14 @@
           <a:ln/>
         </p:spPr>
         <p:txBody>
-          <a:bodyPr wrap="square" lIns="0" tIns="0" rIns="0" bIns="0" rtlCol="0" anchor="ctr">
-            <a:normAutofit/>
-          </a:bodyPr>
+          <a:bodyPr wrap="square" lIns="0" tIns="0" rIns="0" bIns="0" rtlCol="0" anchor="ctr"/>
           <a:lstStyle/>
           <a:p>
             <a:pPr indent="0" marL="0">
               <a:buNone/>
             </a:pPr>
             <a:r>
-              <a:rPr lang="en-US" sz="1600" b="1" dirty="0">
+              <a:rPr lang="en-US" sz="2000" b="1" dirty="0">
                 <a:solidFill>
                   <a:srgbClr val="7B3A8E"/>
                 </a:solidFill>
@@ -8287,14 +8166,14 @@
               <a:buNone/>
             </a:pPr>
             <a:r>
-              <a:rPr lang="en-US" sz="1600" dirty="0">
+              <a:rPr lang="en-US" sz="2000" dirty="0">
                 <a:solidFill>
                   <a:srgbClr val="141B26"/>
                 </a:solidFill>
               </a:rPr>
               <a:t>Predation: abiotic or biotic factor?</a:t>
             </a:r>
-            <a:endParaRPr lang="en-US" sz="1600" dirty="0"/>
+            <a:endParaRPr lang="en-US" sz="2000" dirty="0"/>
           </a:p>
         </p:txBody>
       </p:sp>
@@ -8477,8 +8356,8 @@
         </p:nvSpPr>
         <p:spPr>
           <a:xfrm>
-            <a:off x="548640" y="6053328"/>
-            <a:ext cx="9601200" cy="292608"/>
+            <a:off x="548640" y="6035040"/>
+            <a:ext cx="9601200" cy="310896"/>
           </a:xfrm>
           <a:prstGeom prst="rect">
             <a:avLst/>
@@ -8494,7 +8373,7 @@
               <a:buNone/>
             </a:pPr>
             <a:r>
-              <a:rPr lang="en-US" sz="1200" b="1" dirty="0">
+              <a:rPr lang="en-US" sz="1400" b="1" dirty="0">
                 <a:solidFill>
                   <a:srgbClr val="7B3A8E"/>
                 </a:solidFill>
@@ -8505,14 +8384,14 @@
               <a:buNone/>
             </a:pPr>
             <a:r>
-              <a:rPr lang="en-US" sz="1200" dirty="0">
+              <a:rPr lang="en-US" sz="1400" dirty="0">
                 <a:solidFill>
                   <a:srgbClr val="7B3A8E"/>
                 </a:solidFill>
               </a:rPr>
               <a:t>species   ·   classification</a:t>
             </a:r>
-            <a:endParaRPr lang="en-US" sz="1200" dirty="0"/>
+            <a:endParaRPr lang="en-US" sz="1400" dirty="0"/>
           </a:p>
         </p:txBody>
       </p:sp>
@@ -8534,81 +8413,79 @@
           <a:ln/>
         </p:spPr>
         <p:txBody>
-          <a:bodyPr wrap="square" lIns="0" tIns="0" rIns="0" bIns="0" rtlCol="0" anchor="t">
-            <a:normAutofit/>
-          </a:bodyPr>
-          <a:lstStyle/>
-          <a:p>
-            <a:pPr marL="228600" indent="-228600">
+          <a:bodyPr wrap="square" lIns="0" tIns="0" rIns="0" bIns="0" rtlCol="0" anchor="t"/>
+          <a:lstStyle/>
+          <a:p>
+            <a:pPr marL="304800" indent="-304800">
               <a:spcAft>
-                <a:spcPts val="600"/>
+                <a:spcPts val="800"/>
               </a:spcAft>
               <a:buSzPct val="100000"/>
               <a:buChar char="•"/>
             </a:pPr>
             <a:r>
-              <a:rPr lang="en-US" sz="1700" dirty="0">
+              <a:rPr lang="en-US" sz="2000" dirty="0">
                 <a:solidFill>
                   <a:srgbClr val="141B26"/>
                 </a:solidFill>
               </a:rPr>
               <a:t>Classification is sorting organisms into groups. The smallest group is the species.</a:t>
             </a:r>
-            <a:endParaRPr lang="en-US" sz="1700" dirty="0"/>
-          </a:p>
-          <a:p>
-            <a:pPr marL="228600" indent="-228600">
+            <a:endParaRPr lang="en-US" sz="2000" dirty="0"/>
+          </a:p>
+          <a:p>
+            <a:pPr marL="304800" indent="-304800">
               <a:spcAft>
-                <a:spcPts val="600"/>
+                <a:spcPts val="800"/>
               </a:spcAft>
               <a:buSzPct val="100000"/>
               <a:buChar char="•"/>
             </a:pPr>
             <a:r>
-              <a:rPr lang="en-US" sz="1700" dirty="0">
+              <a:rPr lang="en-US" sz="2000" dirty="0">
                 <a:solidFill>
                   <a:srgbClr val="141B26"/>
                 </a:solidFill>
               </a:rPr>
               <a:t>Members of a species can reproduce together, and their offspring can also reproduce.</a:t>
             </a:r>
-            <a:endParaRPr lang="en-US" sz="1700" dirty="0"/>
-          </a:p>
-          <a:p>
-            <a:pPr marL="228600" indent="-228600">
+            <a:endParaRPr lang="en-US" sz="2000" dirty="0"/>
+          </a:p>
+          <a:p>
+            <a:pPr marL="304800" indent="-304800">
               <a:spcAft>
-                <a:spcPts val="600"/>
+                <a:spcPts val="800"/>
               </a:spcAft>
               <a:buSzPct val="100000"/>
               <a:buChar char="•"/>
             </a:pPr>
             <a:r>
-              <a:rPr lang="en-US" sz="1700" dirty="0">
+              <a:rPr lang="en-US" sz="2000" dirty="0">
                 <a:solidFill>
                   <a:srgbClr val="141B26"/>
                 </a:solidFill>
               </a:rPr>
               <a:t>Environmental variation can make classification difficult.</a:t>
             </a:r>
-            <a:endParaRPr lang="en-US" sz="1700" dirty="0"/>
-          </a:p>
-          <a:p>
-            <a:pPr marL="228600" indent="-228600">
+            <a:endParaRPr lang="en-US" sz="2000" dirty="0"/>
+          </a:p>
+          <a:p>
+            <a:pPr marL="304800" indent="-304800">
               <a:spcAft>
-                <a:spcPts val="600"/>
+                <a:spcPts val="800"/>
               </a:spcAft>
               <a:buSzPct val="100000"/>
               <a:buChar char="•"/>
             </a:pPr>
             <a:r>
-              <a:rPr lang="en-US" sz="1700" dirty="0">
+              <a:rPr lang="en-US" sz="2000" dirty="0">
                 <a:solidFill>
                   <a:srgbClr val="141B26"/>
                 </a:solidFill>
               </a:rPr>
               <a:t>Flores Island, 2003: adult human bones just over 1 m tall. Our species with a poor diet (no iodine), or a different, extinct species?</a:t>
             </a:r>
-            <a:endParaRPr lang="en-US" sz="1700" dirty="0"/>
+            <a:endParaRPr lang="en-US" sz="2000" dirty="0"/>
           </a:p>
         </p:txBody>
       </p:sp>
@@ -8645,7 +8522,7 @@
         <p:spPr>
           <a:xfrm>
             <a:off x="6583680" y="4824532"/>
-            <a:ext cx="5029200" cy="502920"/>
+            <a:ext cx="5029200" cy="548640"/>
           </a:xfrm>
           <a:prstGeom prst="rect">
             <a:avLst/>
@@ -8661,7 +8538,7 @@
               <a:buNone/>
             </a:pPr>
             <a:r>
-              <a:rPr lang="en-US" sz="1100" dirty="0">
+              <a:rPr lang="en-US" sz="1300" dirty="0">
                 <a:solidFill>
                   <a:srgbClr val="141B26"/>
                 </a:solidFill>
@@ -8671,21 +8548,21 @@
             <a:pPr algn="l" indent="0" marL="0">
               <a:buNone/>
             </a:pPr>
-            <a:endParaRPr lang="en-US" sz="1100" dirty="0"/>
+            <a:endParaRPr lang="en-US" sz="1300" dirty="0"/>
           </a:p>
           <a:p>
             <a:pPr algn="l" indent="0" marL="0">
               <a:buNone/>
             </a:pPr>
             <a:r>
-              <a:rPr lang="en-US" sz="800" dirty="0">
+              <a:rPr lang="en-US" sz="900" dirty="0">
                 <a:solidFill>
                   <a:srgbClr val="5B6574"/>
                 </a:solidFill>
               </a:rPr>
               <a:t>Image: Ryan Somma, CC BY-SA 2.0, via Wikimedia Commons</a:t>
             </a:r>
-            <a:endParaRPr lang="en-US" sz="1100" dirty="0"/>
+            <a:endParaRPr lang="en-US" sz="1300" dirty="0"/>
           </a:p>
         </p:txBody>
       </p:sp>
@@ -8732,16 +8609,14 @@
           <a:ln/>
         </p:spPr>
         <p:txBody>
-          <a:bodyPr wrap="square" lIns="0" tIns="0" rIns="0" bIns="0" rtlCol="0" anchor="ctr">
-            <a:normAutofit/>
-          </a:bodyPr>
+          <a:bodyPr wrap="square" lIns="0" tIns="0" rIns="0" bIns="0" rtlCol="0" anchor="ctr"/>
           <a:lstStyle/>
           <a:p>
             <a:pPr indent="0" marL="0">
               <a:buNone/>
             </a:pPr>
             <a:r>
-              <a:rPr lang="en-US" sz="1400" b="1" dirty="0">
+              <a:rPr lang="en-US" sz="1700" b="1" dirty="0">
                 <a:solidFill>
                   <a:srgbClr val="7B3A8E"/>
                 </a:solidFill>
@@ -8752,14 +8627,14 @@
               <a:buNone/>
             </a:pPr>
             <a:r>
-              <a:rPr lang="en-US" sz="1400" dirty="0">
+              <a:rPr lang="en-US" sz="1700" dirty="0">
                 <a:solidFill>
                   <a:srgbClr val="141B26"/>
                 </a:solidFill>
               </a:rPr>
               <a:t>Same species = can breed together and the offspring can breed too.</a:t>
             </a:r>
-            <a:endParaRPr lang="en-US" sz="1400" dirty="0"/>
+            <a:endParaRPr lang="en-US" sz="1700" dirty="0"/>
           </a:p>
         </p:txBody>
       </p:sp>

</xml_diff>